<commit_message>
docs(G1-07): align risk register layout with template
</commit_message>
<xml_diff>
--- a/docs/work/A_PM/risk_register_v1_figures.pptx
+++ b/docs/work/A_PM/risk_register_v1_figures.pptx
@@ -2,15 +2,15 @@
 <file path=ppt/presentation.xml><?xml version="1.0" encoding="utf-8"?>
 <p:presentation xmlns:p="http://schemas.openxmlformats.org/presentationml/2006/main">
   <p:sldMasterIdLst>
-    <p:sldMasterId xmlns:r="http://schemas.openxmlformats.org/officeDocument/2006/relationships" id="2147483648" r:id="R59e313be1fe1466c"/>
+    <p:sldMasterId xmlns:r="http://schemas.openxmlformats.org/officeDocument/2006/relationships" id="2147483648" r:id="Rc22c518ecb374938"/>
   </p:sldMasterIdLst>
   <p:notesMasterIdLst>
-    <p:notesMasterId xmlns:r="http://schemas.openxmlformats.org/officeDocument/2006/relationships" r:id="R249d0d5a454349d3"/>
+    <p:notesMasterId xmlns:r="http://schemas.openxmlformats.org/officeDocument/2006/relationships" r:id="Rf080f0d353c041da"/>
   </p:notesMasterIdLst>
   <p:sldIdLst>
-    <p:sldId xmlns:r="http://schemas.openxmlformats.org/officeDocument/2006/relationships" id="256" r:id="R7d97123dff7b4982"/>
+    <p:sldId xmlns:r="http://schemas.openxmlformats.org/officeDocument/2006/relationships" id="256" r:id="R85226d70359c4226"/>
   </p:sldIdLst>
-  <p:sldSz cx="12192000" cy="6858000"/>
+  <p:sldSz cx="9144000" cy="6858000"/>
   <p:notesSz cx="6858000" cy="9144000"/>
 </p:presentation>
 </file>
@@ -506,7 +506,7 @@
   </p:cSld>
   <p:clrMap bg1="lt1" tx1="dk1" bg2="lt2" tx2="dk2" accent1="accent1" accent2="accent2" accent3="accent3" accent4="accent4" accent5="accent5" accent6="accent6" hlink="hlink" folHlink="folHlink"/>
   <p:sldLayoutIdLst>
-    <p:sldLayoutId xmlns:r="http://schemas.openxmlformats.org/officeDocument/2006/relationships" id="2147483649" r:id="R241c42b9f8cd4774"/>
+    <p:sldLayoutId xmlns:r="http://schemas.openxmlformats.org/officeDocument/2006/relationships" id="2147483649" r:id="Rd0c6f1f3cef04e8b"/>
   </p:sldLayoutIdLst>
   <p:txStyles>
     <p:titleStyle>
@@ -1057,19 +1057,19 @@
           <p:cNvPr id="60" name="">
             <a:extLst xmlns:a="http://schemas.openxmlformats.org/drawingml/2006/main">
               <a:ext uri="{FF2B5EF4-FFF2-40B4-BE49-F238E27FC236}">
-                <a16:creationId xmlns:a16="http://schemas.microsoft.com/office/drawing/2014/main" id="{2E3649DC-520F-4584-8C5F-FC36CB905663}"/>
-              </a:ext>
-            </a:extLst>
-          </p:cNvPr>
-          <p:cNvSpPr>
-            <a:spLocks xmlns:a="http://schemas.openxmlformats.org/drawingml/2006/main" noGrp="1"/>
-          </p:cNvSpPr>
-          <p:nvPr/>
-        </p:nvSpPr>
-        <p:spPr>
-          <a:xfrm xmlns:a="http://schemas.openxmlformats.org/drawingml/2006/main">
-            <a:off x="533400" y="266700"/>
-            <a:ext cx="11125200" cy="438150"/>
+                <a16:creationId xmlns:a16="http://schemas.microsoft.com/office/drawing/2014/main" id="{7287648B-1062-4F6F-8F09-F28BBC2F7037}"/>
+              </a:ext>
+            </a:extLst>
+          </p:cNvPr>
+          <p:cNvSpPr>
+            <a:spLocks xmlns:a="http://schemas.openxmlformats.org/drawingml/2006/main" noGrp="1"/>
+          </p:cNvSpPr>
+          <p:nvPr/>
+        </p:nvSpPr>
+        <p:spPr>
+          <a:xfrm xmlns:a="http://schemas.openxmlformats.org/drawingml/2006/main">
+            <a:off x="438150" y="247650"/>
+            <a:ext cx="8267700" cy="400050"/>
           </a:xfrm>
           <a:prstGeom xmlns:a="http://schemas.openxmlformats.org/drawingml/2006/main" prst="rect">
             <a:avLst/>
@@ -1081,12 +1081,12 @@
         </p:spPr>
         <p:txBody>
           <a:bodyPr xmlns:a="http://schemas.openxmlformats.org/drawingml/2006/main" anchor="ctr">
-            <a:normAutofit fontScale="100000"/>
-          </a:bodyPr>
-          <a:lstStyle xmlns:a="http://schemas.openxmlformats.org/drawingml/2006/main"/>
-          <a:p xmlns:a="http://schemas.openxmlformats.org/drawingml/2006/main">
-            <a:pPr>
-              <a:defRPr sz="2250" b="1">
+            <a:normAutofit fontScale="96428"/>
+          </a:bodyPr>
+          <a:lstStyle xmlns:a="http://schemas.openxmlformats.org/drawingml/2006/main"/>
+          <a:p xmlns:a="http://schemas.openxmlformats.org/drawingml/2006/main">
+            <a:pPr>
+              <a:defRPr sz="2100" b="1">
                 <a:solidFill>
                   <a:srgbClr val="172B3A"/>
                 </a:solidFill>
@@ -1096,7 +1096,7 @@
               </a:defRPr>
             </a:pPr>
             <a:r>
-              <a:rPr sz="2250" b="1">
+              <a:rPr sz="2100" b="1">
                 <a:solidFill>
                   <a:srgbClr val="172B3A"/>
                 </a:solidFill>
@@ -1114,19 +1114,19 @@
           <p:cNvPr id="2" name="">
             <a:extLst xmlns:a="http://schemas.openxmlformats.org/drawingml/2006/main">
               <a:ext uri="{FF2B5EF4-FFF2-40B4-BE49-F238E27FC236}">
-                <a16:creationId xmlns:a16="http://schemas.microsoft.com/office/drawing/2014/main" id="{39CAB69C-6B13-4F7D-8F26-23DAC12EA490}"/>
-              </a:ext>
-            </a:extLst>
-          </p:cNvPr>
-          <p:cNvSpPr>
-            <a:spLocks xmlns:a="http://schemas.openxmlformats.org/drawingml/2006/main" noGrp="1"/>
-          </p:cNvSpPr>
-          <p:nvPr/>
-        </p:nvSpPr>
-        <p:spPr>
-          <a:xfrm xmlns:a="http://schemas.openxmlformats.org/drawingml/2006/main">
-            <a:off x="552450" y="723900"/>
-            <a:ext cx="11049000" cy="228600"/>
+                <a16:creationId xmlns:a16="http://schemas.microsoft.com/office/drawing/2014/main" id="{E3AFD056-88D2-409D-BF1F-1203EBC3C748}"/>
+              </a:ext>
+            </a:extLst>
+          </p:cNvPr>
+          <p:cNvSpPr>
+            <a:spLocks xmlns:a="http://schemas.openxmlformats.org/drawingml/2006/main" noGrp="1"/>
+          </p:cNvSpPr>
+          <p:nvPr/>
+        </p:nvSpPr>
+        <p:spPr>
+          <a:xfrm xmlns:a="http://schemas.openxmlformats.org/drawingml/2006/main">
+            <a:off x="457200" y="666750"/>
+            <a:ext cx="8191500" cy="209550"/>
           </a:xfrm>
           <a:prstGeom xmlns:a="http://schemas.openxmlformats.org/drawingml/2006/main" prst="rect">
             <a:avLst/>
@@ -1138,30 +1138,30 @@
         </p:spPr>
         <p:txBody>
           <a:bodyPr xmlns:a="http://schemas.openxmlformats.org/drawingml/2006/main" anchor="ctr">
-            <a:normAutofit fontScale="92308"/>
-          </a:bodyPr>
-          <a:lstStyle xmlns:a="http://schemas.openxmlformats.org/drawingml/2006/main"/>
-          <a:p xmlns:a="http://schemas.openxmlformats.org/drawingml/2006/main">
-            <a:pPr>
-              <a:defRPr sz="975" b="0">
-                <a:solidFill>
-                  <a:srgbClr val="5D6A75"/>
-                </a:solidFill>
-                <a:latin typeface="Microsoft YaHei"/>
-                <a:ea typeface="Microsoft YaHei"/>
-                <a:cs typeface="Microsoft YaHei"/>
-              </a:defRPr>
-            </a:pPr>
-            <a:r>
-              <a:rPr sz="975" b="0">
-                <a:solidFill>
-                  <a:srgbClr val="5D6A75"/>
-                </a:solidFill>
-                <a:latin typeface="Microsoft YaHei"/>
-                <a:ea typeface="Microsoft YaHei"/>
-                <a:cs typeface="Microsoft YaHei"/>
-              </a:rPr>
-              <a:t>风险登记册 v1：概率与影响的优先级分布。风险评分为内部管理判断，计划关联项待 G1-06 Review 后复核。</a:t>
+            <a:normAutofit fontScale="82623"/>
+          </a:bodyPr>
+          <a:lstStyle xmlns:a="http://schemas.openxmlformats.org/drawingml/2006/main"/>
+          <a:p xmlns:a="http://schemas.openxmlformats.org/drawingml/2006/main">
+            <a:pPr>
+              <a:defRPr sz="938" b="0">
+                <a:solidFill>
+                  <a:srgbClr val="5D6A75"/>
+                </a:solidFill>
+                <a:latin typeface="Microsoft YaHei"/>
+                <a:ea typeface="Microsoft YaHei"/>
+                <a:cs typeface="Microsoft YaHei"/>
+              </a:defRPr>
+            </a:pPr>
+            <a:r>
+              <a:rPr sz="938" b="0">
+                <a:solidFill>
+                  <a:srgbClr val="5D6A75"/>
+                </a:solidFill>
+                <a:latin typeface="Microsoft YaHei"/>
+                <a:ea typeface="Microsoft YaHei"/>
+                <a:cs typeface="Microsoft YaHei"/>
+              </a:rPr>
+              <a:t>风险登记册 v1：概率与影响的优先级分布；计划关联项待 G1-06 Review 后复核。</a:t>
             </a:r>
           </a:p>
         </p:txBody>
@@ -1171,19 +1171,19 @@
           <p:cNvPr id="3" name="">
             <a:extLst xmlns:a="http://schemas.openxmlformats.org/drawingml/2006/main">
               <a:ext uri="{FF2B5EF4-FFF2-40B4-BE49-F238E27FC236}">
-                <a16:creationId xmlns:a16="http://schemas.microsoft.com/office/drawing/2014/main" id="{B1B3D8FF-22C4-4750-B683-4D8EA42C22D8}"/>
-              </a:ext>
-            </a:extLst>
-          </p:cNvPr>
-          <p:cNvSpPr>
-            <a:spLocks xmlns:a="http://schemas.openxmlformats.org/drawingml/2006/main" noGrp="1"/>
-          </p:cNvSpPr>
-          <p:nvPr/>
-        </p:nvSpPr>
-        <p:spPr>
-          <a:xfrm xmlns:a="http://schemas.openxmlformats.org/drawingml/2006/main">
-            <a:off x="533400" y="1028700"/>
-            <a:ext cx="11125200" cy="19050"/>
+                <a16:creationId xmlns:a16="http://schemas.microsoft.com/office/drawing/2014/main" id="{3EF2E929-0854-4574-A515-BDED9896B641}"/>
+              </a:ext>
+            </a:extLst>
+          </p:cNvPr>
+          <p:cNvSpPr>
+            <a:spLocks xmlns:a="http://schemas.openxmlformats.org/drawingml/2006/main" noGrp="1"/>
+          </p:cNvSpPr>
+          <p:nvPr/>
+        </p:nvSpPr>
+        <p:spPr>
+          <a:xfrm xmlns:a="http://schemas.openxmlformats.org/drawingml/2006/main">
+            <a:off x="438150" y="962025"/>
+            <a:ext cx="8267700" cy="19050"/>
           </a:xfrm>
           <a:prstGeom xmlns:a="http://schemas.openxmlformats.org/drawingml/2006/main" prst="rect">
             <a:avLst/>
@@ -1201,19 +1201,19 @@
           <p:cNvPr id="4" name="">
             <a:extLst xmlns:a="http://schemas.openxmlformats.org/drawingml/2006/main">
               <a:ext uri="{FF2B5EF4-FFF2-40B4-BE49-F238E27FC236}">
-                <a16:creationId xmlns:a16="http://schemas.microsoft.com/office/drawing/2014/main" id="{141C693E-8D41-4426-BEB1-7AD30EBA5ADC}"/>
-              </a:ext>
-            </a:extLst>
-          </p:cNvPr>
-          <p:cNvSpPr>
-            <a:spLocks xmlns:a="http://schemas.openxmlformats.org/drawingml/2006/main" noGrp="1"/>
-          </p:cNvSpPr>
-          <p:nvPr/>
-        </p:nvSpPr>
-        <p:spPr>
-          <a:xfrm xmlns:a="http://schemas.openxmlformats.org/drawingml/2006/main">
-            <a:off x="552450" y="3048000"/>
-            <a:ext cx="1952625" cy="323850"/>
+                <a16:creationId xmlns:a16="http://schemas.microsoft.com/office/drawing/2014/main" id="{381C795F-A18F-4ACA-9CF3-E9E22D719CB4}"/>
+              </a:ext>
+            </a:extLst>
+          </p:cNvPr>
+          <p:cNvSpPr>
+            <a:spLocks xmlns:a="http://schemas.openxmlformats.org/drawingml/2006/main" noGrp="1"/>
+          </p:cNvSpPr>
+          <p:nvPr/>
+        </p:nvSpPr>
+        <p:spPr>
+          <a:xfrm xmlns:a="http://schemas.openxmlformats.org/drawingml/2006/main">
+            <a:off x="381000" y="2857500"/>
+            <a:ext cx="1809750" cy="323850"/>
           </a:xfrm>
           <a:prstGeom xmlns:a="http://schemas.openxmlformats.org/drawingml/2006/main" prst="rect">
             <a:avLst/>
@@ -1230,7 +1230,7 @@
           <a:lstStyle xmlns:a="http://schemas.openxmlformats.org/drawingml/2006/main"/>
           <a:p xmlns:a="http://schemas.openxmlformats.org/drawingml/2006/main">
             <a:pPr>
-              <a:defRPr sz="1350" b="1">
+              <a:defRPr sz="1275" b="1">
                 <a:solidFill>
                   <a:srgbClr val="172B3A"/>
                 </a:solidFill>
@@ -1240,7 +1240,7 @@
               </a:defRPr>
             </a:pPr>
             <a:r>
-              <a:rPr sz="1350" b="1">
+              <a:rPr sz="1275" b="1">
                 <a:solidFill>
                   <a:srgbClr val="172B3A"/>
                 </a:solidFill>
@@ -1258,19 +1258,19 @@
           <p:cNvPr id="5" name="">
             <a:extLst xmlns:a="http://schemas.openxmlformats.org/drawingml/2006/main">
               <a:ext uri="{FF2B5EF4-FFF2-40B4-BE49-F238E27FC236}">
-                <a16:creationId xmlns:a16="http://schemas.microsoft.com/office/drawing/2014/main" id="{8CB31FA2-601F-4BBF-96A5-82239B3148D2}"/>
-              </a:ext>
-            </a:extLst>
-          </p:cNvPr>
-          <p:cNvSpPr>
-            <a:spLocks xmlns:a="http://schemas.openxmlformats.org/drawingml/2006/main" noGrp="1"/>
-          </p:cNvSpPr>
-          <p:nvPr/>
-        </p:nvSpPr>
-        <p:spPr>
-          <a:xfrm xmlns:a="http://schemas.openxmlformats.org/drawingml/2006/main">
-            <a:off x="6191250" y="1143000"/>
-            <a:ext cx="2476500" cy="285750"/>
+                <a16:creationId xmlns:a16="http://schemas.microsoft.com/office/drawing/2014/main" id="{24F2A8A5-4E6C-4698-A1C3-A0A7329B0EAF}"/>
+              </a:ext>
+            </a:extLst>
+          </p:cNvPr>
+          <p:cNvSpPr>
+            <a:spLocks xmlns:a="http://schemas.openxmlformats.org/drawingml/2006/main" noGrp="1"/>
+          </p:cNvSpPr>
+          <p:nvPr/>
+        </p:nvSpPr>
+        <p:spPr>
+          <a:xfrm xmlns:a="http://schemas.openxmlformats.org/drawingml/2006/main">
+            <a:off x="6048375" y="1066800"/>
+            <a:ext cx="1809750" cy="266700"/>
           </a:xfrm>
           <a:prstGeom xmlns:a="http://schemas.openxmlformats.org/drawingml/2006/main" prst="rect">
             <a:avLst/>
@@ -1282,12 +1282,12 @@
         </p:spPr>
         <p:txBody>
           <a:bodyPr xmlns:a="http://schemas.openxmlformats.org/drawingml/2006/main" anchor="ctr">
-            <a:normAutofit fontScale="94444"/>
-          </a:bodyPr>
-          <a:lstStyle xmlns:a="http://schemas.openxmlformats.org/drawingml/2006/main"/>
-          <a:p xmlns:a="http://schemas.openxmlformats.org/drawingml/2006/main">
-            <a:pPr>
-              <a:defRPr sz="1350" b="1">
+            <a:normAutofit fontScale="90196"/>
+          </a:bodyPr>
+          <a:lstStyle xmlns:a="http://schemas.openxmlformats.org/drawingml/2006/main"/>
+          <a:p xmlns:a="http://schemas.openxmlformats.org/drawingml/2006/main">
+            <a:pPr>
+              <a:defRPr sz="1275" b="1">
                 <a:solidFill>
                   <a:srgbClr val="172B3A"/>
                 </a:solidFill>
@@ -1297,7 +1297,7 @@
               </a:defRPr>
             </a:pPr>
             <a:r>
-              <a:rPr sz="1350" b="1">
+              <a:rPr sz="1275" b="1">
                 <a:solidFill>
                   <a:srgbClr val="172B3A"/>
                 </a:solidFill>
@@ -1315,19 +1315,19 @@
           <p:cNvPr id="6" name="">
             <a:extLst xmlns:a="http://schemas.openxmlformats.org/drawingml/2006/main">
               <a:ext uri="{FF2B5EF4-FFF2-40B4-BE49-F238E27FC236}">
-                <a16:creationId xmlns:a16="http://schemas.microsoft.com/office/drawing/2014/main" id="{D86ED4A2-50D1-4F14-82FE-79AF1FE62710}"/>
-              </a:ext>
-            </a:extLst>
-          </p:cNvPr>
-          <p:cNvSpPr>
-            <a:spLocks xmlns:a="http://schemas.openxmlformats.org/drawingml/2006/main" noGrp="1"/>
-          </p:cNvSpPr>
-          <p:nvPr/>
-        </p:nvSpPr>
-        <p:spPr>
-          <a:xfrm xmlns:a="http://schemas.openxmlformats.org/drawingml/2006/main">
-            <a:off x="2857500" y="1219200"/>
-            <a:ext cx="857250" cy="266700"/>
+                <a16:creationId xmlns:a16="http://schemas.microsoft.com/office/drawing/2014/main" id="{CE3C255F-2F42-4039-BF8D-CA2AF09E7F9C}"/>
+              </a:ext>
+            </a:extLst>
+          </p:cNvPr>
+          <p:cNvSpPr>
+            <a:spLocks xmlns:a="http://schemas.openxmlformats.org/drawingml/2006/main" noGrp="1"/>
+          </p:cNvSpPr>
+          <p:nvPr/>
+        </p:nvSpPr>
+        <p:spPr>
+          <a:xfrm xmlns:a="http://schemas.openxmlformats.org/drawingml/2006/main">
+            <a:off x="2714625" y="1143000"/>
+            <a:ext cx="781050" cy="247650"/>
           </a:xfrm>
           <a:prstGeom xmlns:a="http://schemas.openxmlformats.org/drawingml/2006/main" prst="rect">
             <a:avLst/>
@@ -1339,12 +1339,12 @@
         </p:spPr>
         <p:txBody>
           <a:bodyPr xmlns:a="http://schemas.openxmlformats.org/drawingml/2006/main" anchor="ctr">
-            <a:normAutofit fontScale="100000"/>
-          </a:bodyPr>
-          <a:lstStyle xmlns:a="http://schemas.openxmlformats.org/drawingml/2006/main"/>
-          <a:p xmlns:a="http://schemas.openxmlformats.org/drawingml/2006/main">
-            <a:pPr>
-              <a:defRPr sz="1125" b="1">
+            <a:normAutofit fontScale="97619"/>
+          </a:bodyPr>
+          <a:lstStyle xmlns:a="http://schemas.openxmlformats.org/drawingml/2006/main"/>
+          <a:p xmlns:a="http://schemas.openxmlformats.org/drawingml/2006/main">
+            <a:pPr>
+              <a:defRPr sz="1050" b="1">
                 <a:solidFill>
                   <a:srgbClr val="172B3A"/>
                 </a:solidFill>
@@ -1354,7 +1354,7 @@
               </a:defRPr>
             </a:pPr>
             <a:r>
-              <a:rPr sz="1125" b="1">
+              <a:rPr sz="1050" b="1">
                 <a:solidFill>
                   <a:srgbClr val="172B3A"/>
                 </a:solidFill>
@@ -1372,19 +1372,19 @@
           <p:cNvPr id="7" name="">
             <a:extLst xmlns:a="http://schemas.openxmlformats.org/drawingml/2006/main">
               <a:ext uri="{FF2B5EF4-FFF2-40B4-BE49-F238E27FC236}">
-                <a16:creationId xmlns:a16="http://schemas.microsoft.com/office/drawing/2014/main" id="{EC9CD657-6AB5-43F6-9C4F-53265029F83D}"/>
-              </a:ext>
-            </a:extLst>
-          </p:cNvPr>
-          <p:cNvSpPr>
-            <a:spLocks xmlns:a="http://schemas.openxmlformats.org/drawingml/2006/main" noGrp="1"/>
-          </p:cNvSpPr>
-          <p:nvPr/>
-        </p:nvSpPr>
-        <p:spPr>
-          <a:xfrm xmlns:a="http://schemas.openxmlformats.org/drawingml/2006/main">
-            <a:off x="3714750" y="1219200"/>
-            <a:ext cx="857250" cy="266700"/>
+                <a16:creationId xmlns:a16="http://schemas.microsoft.com/office/drawing/2014/main" id="{9C511556-AD05-4F49-8CD5-A55756B33343}"/>
+              </a:ext>
+            </a:extLst>
+          </p:cNvPr>
+          <p:cNvSpPr>
+            <a:spLocks xmlns:a="http://schemas.openxmlformats.org/drawingml/2006/main" noGrp="1"/>
+          </p:cNvSpPr>
+          <p:nvPr/>
+        </p:nvSpPr>
+        <p:spPr>
+          <a:xfrm xmlns:a="http://schemas.openxmlformats.org/drawingml/2006/main">
+            <a:off x="3495675" y="1143000"/>
+            <a:ext cx="781050" cy="247650"/>
           </a:xfrm>
           <a:prstGeom xmlns:a="http://schemas.openxmlformats.org/drawingml/2006/main" prst="rect">
             <a:avLst/>
@@ -1396,12 +1396,12 @@
         </p:spPr>
         <p:txBody>
           <a:bodyPr xmlns:a="http://schemas.openxmlformats.org/drawingml/2006/main" anchor="ctr">
-            <a:normAutofit fontScale="100000"/>
-          </a:bodyPr>
-          <a:lstStyle xmlns:a="http://schemas.openxmlformats.org/drawingml/2006/main"/>
-          <a:p xmlns:a="http://schemas.openxmlformats.org/drawingml/2006/main">
-            <a:pPr>
-              <a:defRPr sz="1125" b="1">
+            <a:normAutofit fontScale="97619"/>
+          </a:bodyPr>
+          <a:lstStyle xmlns:a="http://schemas.openxmlformats.org/drawingml/2006/main"/>
+          <a:p xmlns:a="http://schemas.openxmlformats.org/drawingml/2006/main">
+            <a:pPr>
+              <a:defRPr sz="1050" b="1">
                 <a:solidFill>
                   <a:srgbClr val="172B3A"/>
                 </a:solidFill>
@@ -1411,7 +1411,7 @@
               </a:defRPr>
             </a:pPr>
             <a:r>
-              <a:rPr sz="1125" b="1">
+              <a:rPr sz="1050" b="1">
                 <a:solidFill>
                   <a:srgbClr val="172B3A"/>
                 </a:solidFill>
@@ -1429,19 +1429,19 @@
           <p:cNvPr id="8" name="">
             <a:extLst xmlns:a="http://schemas.openxmlformats.org/drawingml/2006/main">
               <a:ext uri="{FF2B5EF4-FFF2-40B4-BE49-F238E27FC236}">
-                <a16:creationId xmlns:a16="http://schemas.microsoft.com/office/drawing/2014/main" id="{D188BCF0-1B74-44F6-A4B2-CF68DC65B672}"/>
-              </a:ext>
-            </a:extLst>
-          </p:cNvPr>
-          <p:cNvSpPr>
-            <a:spLocks xmlns:a="http://schemas.openxmlformats.org/drawingml/2006/main" noGrp="1"/>
-          </p:cNvSpPr>
-          <p:nvPr/>
-        </p:nvSpPr>
-        <p:spPr>
-          <a:xfrm xmlns:a="http://schemas.openxmlformats.org/drawingml/2006/main">
-            <a:off x="4572000" y="1219200"/>
-            <a:ext cx="857250" cy="266700"/>
+                <a16:creationId xmlns:a16="http://schemas.microsoft.com/office/drawing/2014/main" id="{A0FA960B-F132-4470-93E2-300A1ECB3C83}"/>
+              </a:ext>
+            </a:extLst>
+          </p:cNvPr>
+          <p:cNvSpPr>
+            <a:spLocks xmlns:a="http://schemas.openxmlformats.org/drawingml/2006/main" noGrp="1"/>
+          </p:cNvSpPr>
+          <p:nvPr/>
+        </p:nvSpPr>
+        <p:spPr>
+          <a:xfrm xmlns:a="http://schemas.openxmlformats.org/drawingml/2006/main">
+            <a:off x="4276725" y="1143000"/>
+            <a:ext cx="781050" cy="247650"/>
           </a:xfrm>
           <a:prstGeom xmlns:a="http://schemas.openxmlformats.org/drawingml/2006/main" prst="rect">
             <a:avLst/>
@@ -1453,12 +1453,12 @@
         </p:spPr>
         <p:txBody>
           <a:bodyPr xmlns:a="http://schemas.openxmlformats.org/drawingml/2006/main" anchor="ctr">
-            <a:normAutofit fontScale="100000"/>
-          </a:bodyPr>
-          <a:lstStyle xmlns:a="http://schemas.openxmlformats.org/drawingml/2006/main"/>
-          <a:p xmlns:a="http://schemas.openxmlformats.org/drawingml/2006/main">
-            <a:pPr>
-              <a:defRPr sz="1125" b="1">
+            <a:normAutofit fontScale="97619"/>
+          </a:bodyPr>
+          <a:lstStyle xmlns:a="http://schemas.openxmlformats.org/drawingml/2006/main"/>
+          <a:p xmlns:a="http://schemas.openxmlformats.org/drawingml/2006/main">
+            <a:pPr>
+              <a:defRPr sz="1050" b="1">
                 <a:solidFill>
                   <a:srgbClr val="172B3A"/>
                 </a:solidFill>
@@ -1468,7 +1468,7 @@
               </a:defRPr>
             </a:pPr>
             <a:r>
-              <a:rPr sz="1125" b="1">
+              <a:rPr sz="1050" b="1">
                 <a:solidFill>
                   <a:srgbClr val="172B3A"/>
                 </a:solidFill>
@@ -1486,19 +1486,19 @@
           <p:cNvPr id="9" name="">
             <a:extLst xmlns:a="http://schemas.openxmlformats.org/drawingml/2006/main">
               <a:ext uri="{FF2B5EF4-FFF2-40B4-BE49-F238E27FC236}">
-                <a16:creationId xmlns:a16="http://schemas.microsoft.com/office/drawing/2014/main" id="{87721CE2-C2DA-4A0B-982A-ADC6A2943CBF}"/>
-              </a:ext>
-            </a:extLst>
-          </p:cNvPr>
-          <p:cNvSpPr>
-            <a:spLocks xmlns:a="http://schemas.openxmlformats.org/drawingml/2006/main" noGrp="1"/>
-          </p:cNvSpPr>
-          <p:nvPr/>
-        </p:nvSpPr>
-        <p:spPr>
-          <a:xfrm xmlns:a="http://schemas.openxmlformats.org/drawingml/2006/main">
-            <a:off x="5429250" y="1219200"/>
-            <a:ext cx="857250" cy="266700"/>
+                <a16:creationId xmlns:a16="http://schemas.microsoft.com/office/drawing/2014/main" id="{608E828B-C1D6-4F81-BD14-6B58BE7DF978}"/>
+              </a:ext>
+            </a:extLst>
+          </p:cNvPr>
+          <p:cNvSpPr>
+            <a:spLocks xmlns:a="http://schemas.openxmlformats.org/drawingml/2006/main" noGrp="1"/>
+          </p:cNvSpPr>
+          <p:nvPr/>
+        </p:nvSpPr>
+        <p:spPr>
+          <a:xfrm xmlns:a="http://schemas.openxmlformats.org/drawingml/2006/main">
+            <a:off x="5057775" y="1143000"/>
+            <a:ext cx="781050" cy="247650"/>
           </a:xfrm>
           <a:prstGeom xmlns:a="http://schemas.openxmlformats.org/drawingml/2006/main" prst="rect">
             <a:avLst/>
@@ -1510,12 +1510,12 @@
         </p:spPr>
         <p:txBody>
           <a:bodyPr xmlns:a="http://schemas.openxmlformats.org/drawingml/2006/main" anchor="ctr">
-            <a:normAutofit fontScale="100000"/>
-          </a:bodyPr>
-          <a:lstStyle xmlns:a="http://schemas.openxmlformats.org/drawingml/2006/main"/>
-          <a:p xmlns:a="http://schemas.openxmlformats.org/drawingml/2006/main">
-            <a:pPr>
-              <a:defRPr sz="1125" b="1">
+            <a:normAutofit fontScale="97619"/>
+          </a:bodyPr>
+          <a:lstStyle xmlns:a="http://schemas.openxmlformats.org/drawingml/2006/main"/>
+          <a:p xmlns:a="http://schemas.openxmlformats.org/drawingml/2006/main">
+            <a:pPr>
+              <a:defRPr sz="1050" b="1">
                 <a:solidFill>
                   <a:srgbClr val="172B3A"/>
                 </a:solidFill>
@@ -1525,7 +1525,7 @@
               </a:defRPr>
             </a:pPr>
             <a:r>
-              <a:rPr sz="1125" b="1">
+              <a:rPr sz="1050" b="1">
                 <a:solidFill>
                   <a:srgbClr val="172B3A"/>
                 </a:solidFill>
@@ -1543,19 +1543,19 @@
           <p:cNvPr id="10" name="">
             <a:extLst xmlns:a="http://schemas.openxmlformats.org/drawingml/2006/main">
               <a:ext uri="{FF2B5EF4-FFF2-40B4-BE49-F238E27FC236}">
-                <a16:creationId xmlns:a16="http://schemas.microsoft.com/office/drawing/2014/main" id="{D538F9BF-B3C7-44DE-AF61-866FE66BFDEC}"/>
-              </a:ext>
-            </a:extLst>
-          </p:cNvPr>
-          <p:cNvSpPr>
-            <a:spLocks xmlns:a="http://schemas.openxmlformats.org/drawingml/2006/main" noGrp="1"/>
-          </p:cNvSpPr>
-          <p:nvPr/>
-        </p:nvSpPr>
-        <p:spPr>
-          <a:xfrm xmlns:a="http://schemas.openxmlformats.org/drawingml/2006/main">
-            <a:off x="6286500" y="1219200"/>
-            <a:ext cx="857250" cy="266700"/>
+                <a16:creationId xmlns:a16="http://schemas.microsoft.com/office/drawing/2014/main" id="{56660163-EDB3-4914-86B3-262B46D9684D}"/>
+              </a:ext>
+            </a:extLst>
+          </p:cNvPr>
+          <p:cNvSpPr>
+            <a:spLocks xmlns:a="http://schemas.openxmlformats.org/drawingml/2006/main" noGrp="1"/>
+          </p:cNvSpPr>
+          <p:nvPr/>
+        </p:nvSpPr>
+        <p:spPr>
+          <a:xfrm xmlns:a="http://schemas.openxmlformats.org/drawingml/2006/main">
+            <a:off x="5838825" y="1143000"/>
+            <a:ext cx="781050" cy="247650"/>
           </a:xfrm>
           <a:prstGeom xmlns:a="http://schemas.openxmlformats.org/drawingml/2006/main" prst="rect">
             <a:avLst/>
@@ -1567,12 +1567,12 @@
         </p:spPr>
         <p:txBody>
           <a:bodyPr xmlns:a="http://schemas.openxmlformats.org/drawingml/2006/main" anchor="ctr">
-            <a:normAutofit fontScale="100000"/>
-          </a:bodyPr>
-          <a:lstStyle xmlns:a="http://schemas.openxmlformats.org/drawingml/2006/main"/>
-          <a:p xmlns:a="http://schemas.openxmlformats.org/drawingml/2006/main">
-            <a:pPr>
-              <a:defRPr sz="1125" b="1">
+            <a:normAutofit fontScale="97619"/>
+          </a:bodyPr>
+          <a:lstStyle xmlns:a="http://schemas.openxmlformats.org/drawingml/2006/main"/>
+          <a:p xmlns:a="http://schemas.openxmlformats.org/drawingml/2006/main">
+            <a:pPr>
+              <a:defRPr sz="1050" b="1">
                 <a:solidFill>
                   <a:srgbClr val="172B3A"/>
                 </a:solidFill>
@@ -1582,7 +1582,7 @@
               </a:defRPr>
             </a:pPr>
             <a:r>
-              <a:rPr sz="1125" b="1">
+              <a:rPr sz="1050" b="1">
                 <a:solidFill>
                   <a:srgbClr val="172B3A"/>
                 </a:solidFill>
@@ -1600,19 +1600,19 @@
           <p:cNvPr id="11" name="">
             <a:extLst xmlns:a="http://schemas.openxmlformats.org/drawingml/2006/main">
               <a:ext uri="{FF2B5EF4-FFF2-40B4-BE49-F238E27FC236}">
-                <a16:creationId xmlns:a16="http://schemas.microsoft.com/office/drawing/2014/main" id="{76D84BD7-7D6B-415C-ACD8-7BF5BC77B08E}"/>
-              </a:ext>
-            </a:extLst>
-          </p:cNvPr>
-          <p:cNvSpPr>
-            <a:spLocks xmlns:a="http://schemas.openxmlformats.org/drawingml/2006/main" noGrp="1"/>
-          </p:cNvSpPr>
-          <p:nvPr/>
-        </p:nvSpPr>
-        <p:spPr>
-          <a:xfrm xmlns:a="http://schemas.openxmlformats.org/drawingml/2006/main">
-            <a:off x="2381250" y="4953000"/>
-            <a:ext cx="361950" cy="857250"/>
+                <a16:creationId xmlns:a16="http://schemas.microsoft.com/office/drawing/2014/main" id="{3B9D941F-6056-4E72-8F9E-CE8D27C9F25A}"/>
+              </a:ext>
+            </a:extLst>
+          </p:cNvPr>
+          <p:cNvSpPr>
+            <a:spLocks xmlns:a="http://schemas.openxmlformats.org/drawingml/2006/main" noGrp="1"/>
+          </p:cNvSpPr>
+          <p:nvPr/>
+        </p:nvSpPr>
+        <p:spPr>
+          <a:xfrm xmlns:a="http://schemas.openxmlformats.org/drawingml/2006/main">
+            <a:off x="2305050" y="4552950"/>
+            <a:ext cx="342900" cy="781050"/>
           </a:xfrm>
           <a:prstGeom xmlns:a="http://schemas.openxmlformats.org/drawingml/2006/main" prst="rect">
             <a:avLst/>
@@ -1629,7 +1629,7 @@
           <a:lstStyle xmlns:a="http://schemas.openxmlformats.org/drawingml/2006/main"/>
           <a:p xmlns:a="http://schemas.openxmlformats.org/drawingml/2006/main">
             <a:pPr>
-              <a:defRPr sz="1125" b="1">
+              <a:defRPr sz="1050" b="1">
                 <a:solidFill>
                   <a:srgbClr val="172B3A"/>
                 </a:solidFill>
@@ -1639,7 +1639,7 @@
               </a:defRPr>
             </a:pPr>
             <a:r>
-              <a:rPr sz="1125" b="1">
+              <a:rPr sz="1050" b="1">
                 <a:solidFill>
                   <a:srgbClr val="172B3A"/>
                 </a:solidFill>
@@ -1657,19 +1657,19 @@
           <p:cNvPr id="12" name="">
             <a:extLst xmlns:a="http://schemas.openxmlformats.org/drawingml/2006/main">
               <a:ext uri="{FF2B5EF4-FFF2-40B4-BE49-F238E27FC236}">
-                <a16:creationId xmlns:a16="http://schemas.microsoft.com/office/drawing/2014/main" id="{6EF2CFAD-78C3-4AFC-80F1-BE86C18C6A15}"/>
-              </a:ext>
-            </a:extLst>
-          </p:cNvPr>
-          <p:cNvSpPr>
-            <a:spLocks xmlns:a="http://schemas.openxmlformats.org/drawingml/2006/main" noGrp="1"/>
-          </p:cNvSpPr>
-          <p:nvPr/>
-        </p:nvSpPr>
-        <p:spPr>
-          <a:xfrm xmlns:a="http://schemas.openxmlformats.org/drawingml/2006/main">
-            <a:off x="2381250" y="4095750"/>
-            <a:ext cx="361950" cy="857250"/>
+                <a16:creationId xmlns:a16="http://schemas.microsoft.com/office/drawing/2014/main" id="{15973C20-AD1F-4B2A-B383-72B503C53FFD}"/>
+              </a:ext>
+            </a:extLst>
+          </p:cNvPr>
+          <p:cNvSpPr>
+            <a:spLocks xmlns:a="http://schemas.openxmlformats.org/drawingml/2006/main" noGrp="1"/>
+          </p:cNvSpPr>
+          <p:nvPr/>
+        </p:nvSpPr>
+        <p:spPr>
+          <a:xfrm xmlns:a="http://schemas.openxmlformats.org/drawingml/2006/main">
+            <a:off x="2305050" y="3771900"/>
+            <a:ext cx="342900" cy="781050"/>
           </a:xfrm>
           <a:prstGeom xmlns:a="http://schemas.openxmlformats.org/drawingml/2006/main" prst="rect">
             <a:avLst/>
@@ -1686,7 +1686,7 @@
           <a:lstStyle xmlns:a="http://schemas.openxmlformats.org/drawingml/2006/main"/>
           <a:p xmlns:a="http://schemas.openxmlformats.org/drawingml/2006/main">
             <a:pPr>
-              <a:defRPr sz="1125" b="1">
+              <a:defRPr sz="1050" b="1">
                 <a:solidFill>
                   <a:srgbClr val="172B3A"/>
                 </a:solidFill>
@@ -1696,7 +1696,7 @@
               </a:defRPr>
             </a:pPr>
             <a:r>
-              <a:rPr sz="1125" b="1">
+              <a:rPr sz="1050" b="1">
                 <a:solidFill>
                   <a:srgbClr val="172B3A"/>
                 </a:solidFill>
@@ -1714,19 +1714,19 @@
           <p:cNvPr id="13" name="">
             <a:extLst xmlns:a="http://schemas.openxmlformats.org/drawingml/2006/main">
               <a:ext uri="{FF2B5EF4-FFF2-40B4-BE49-F238E27FC236}">
-                <a16:creationId xmlns:a16="http://schemas.microsoft.com/office/drawing/2014/main" id="{48C42907-FEA0-4EE1-AFA1-839C59FFD564}"/>
-              </a:ext>
-            </a:extLst>
-          </p:cNvPr>
-          <p:cNvSpPr>
-            <a:spLocks xmlns:a="http://schemas.openxmlformats.org/drawingml/2006/main" noGrp="1"/>
-          </p:cNvSpPr>
-          <p:nvPr/>
-        </p:nvSpPr>
-        <p:spPr>
-          <a:xfrm xmlns:a="http://schemas.openxmlformats.org/drawingml/2006/main">
-            <a:off x="2381250" y="3238500"/>
-            <a:ext cx="361950" cy="857250"/>
+                <a16:creationId xmlns:a16="http://schemas.microsoft.com/office/drawing/2014/main" id="{0151C6C2-7D93-4C9C-A1C1-6B5AB2DD8127}"/>
+              </a:ext>
+            </a:extLst>
+          </p:cNvPr>
+          <p:cNvSpPr>
+            <a:spLocks xmlns:a="http://schemas.openxmlformats.org/drawingml/2006/main" noGrp="1"/>
+          </p:cNvSpPr>
+          <p:nvPr/>
+        </p:nvSpPr>
+        <p:spPr>
+          <a:xfrm xmlns:a="http://schemas.openxmlformats.org/drawingml/2006/main">
+            <a:off x="2305050" y="2990850"/>
+            <a:ext cx="342900" cy="781050"/>
           </a:xfrm>
           <a:prstGeom xmlns:a="http://schemas.openxmlformats.org/drawingml/2006/main" prst="rect">
             <a:avLst/>
@@ -1743,7 +1743,7 @@
           <a:lstStyle xmlns:a="http://schemas.openxmlformats.org/drawingml/2006/main"/>
           <a:p xmlns:a="http://schemas.openxmlformats.org/drawingml/2006/main">
             <a:pPr>
-              <a:defRPr sz="1125" b="1">
+              <a:defRPr sz="1050" b="1">
                 <a:solidFill>
                   <a:srgbClr val="172B3A"/>
                 </a:solidFill>
@@ -1753,7 +1753,7 @@
               </a:defRPr>
             </a:pPr>
             <a:r>
-              <a:rPr sz="1125" b="1">
+              <a:rPr sz="1050" b="1">
                 <a:solidFill>
                   <a:srgbClr val="172B3A"/>
                 </a:solidFill>
@@ -1771,19 +1771,19 @@
           <p:cNvPr id="14" name="">
             <a:extLst xmlns:a="http://schemas.openxmlformats.org/drawingml/2006/main">
               <a:ext uri="{FF2B5EF4-FFF2-40B4-BE49-F238E27FC236}">
-                <a16:creationId xmlns:a16="http://schemas.microsoft.com/office/drawing/2014/main" id="{D123B1A4-978F-49DF-B3C1-B22A335DC68B}"/>
-              </a:ext>
-            </a:extLst>
-          </p:cNvPr>
-          <p:cNvSpPr>
-            <a:spLocks xmlns:a="http://schemas.openxmlformats.org/drawingml/2006/main" noGrp="1"/>
-          </p:cNvSpPr>
-          <p:nvPr/>
-        </p:nvSpPr>
-        <p:spPr>
-          <a:xfrm xmlns:a="http://schemas.openxmlformats.org/drawingml/2006/main">
-            <a:off x="2381250" y="2381250"/>
-            <a:ext cx="361950" cy="857250"/>
+                <a16:creationId xmlns:a16="http://schemas.microsoft.com/office/drawing/2014/main" id="{E57330F5-E8EF-42FB-9590-46F14EE0DE26}"/>
+              </a:ext>
+            </a:extLst>
+          </p:cNvPr>
+          <p:cNvSpPr>
+            <a:spLocks xmlns:a="http://schemas.openxmlformats.org/drawingml/2006/main" noGrp="1"/>
+          </p:cNvSpPr>
+          <p:nvPr/>
+        </p:nvSpPr>
+        <p:spPr>
+          <a:xfrm xmlns:a="http://schemas.openxmlformats.org/drawingml/2006/main">
+            <a:off x="2305050" y="2209800"/>
+            <a:ext cx="342900" cy="781050"/>
           </a:xfrm>
           <a:prstGeom xmlns:a="http://schemas.openxmlformats.org/drawingml/2006/main" prst="rect">
             <a:avLst/>
@@ -1800,7 +1800,7 @@
           <a:lstStyle xmlns:a="http://schemas.openxmlformats.org/drawingml/2006/main"/>
           <a:p xmlns:a="http://schemas.openxmlformats.org/drawingml/2006/main">
             <a:pPr>
-              <a:defRPr sz="1125" b="1">
+              <a:defRPr sz="1050" b="1">
                 <a:solidFill>
                   <a:srgbClr val="172B3A"/>
                 </a:solidFill>
@@ -1810,7 +1810,7 @@
               </a:defRPr>
             </a:pPr>
             <a:r>
-              <a:rPr sz="1125" b="1">
+              <a:rPr sz="1050" b="1">
                 <a:solidFill>
                   <a:srgbClr val="172B3A"/>
                 </a:solidFill>
@@ -1828,19 +1828,19 @@
           <p:cNvPr id="15" name="">
             <a:extLst xmlns:a="http://schemas.openxmlformats.org/drawingml/2006/main">
               <a:ext uri="{FF2B5EF4-FFF2-40B4-BE49-F238E27FC236}">
-                <a16:creationId xmlns:a16="http://schemas.microsoft.com/office/drawing/2014/main" id="{FC8B9125-7CF6-4FC1-BBF4-D7AD906911CA}"/>
-              </a:ext>
-            </a:extLst>
-          </p:cNvPr>
-          <p:cNvSpPr>
-            <a:spLocks xmlns:a="http://schemas.openxmlformats.org/drawingml/2006/main" noGrp="1"/>
-          </p:cNvSpPr>
-          <p:nvPr/>
-        </p:nvSpPr>
-        <p:spPr>
-          <a:xfrm xmlns:a="http://schemas.openxmlformats.org/drawingml/2006/main">
-            <a:off x="2381250" y="1524000"/>
-            <a:ext cx="361950" cy="857250"/>
+                <a16:creationId xmlns:a16="http://schemas.microsoft.com/office/drawing/2014/main" id="{D60C2C01-10F1-4B19-8BCA-9B20858632A9}"/>
+              </a:ext>
+            </a:extLst>
+          </p:cNvPr>
+          <p:cNvSpPr>
+            <a:spLocks xmlns:a="http://schemas.openxmlformats.org/drawingml/2006/main" noGrp="1"/>
+          </p:cNvSpPr>
+          <p:nvPr/>
+        </p:nvSpPr>
+        <p:spPr>
+          <a:xfrm xmlns:a="http://schemas.openxmlformats.org/drawingml/2006/main">
+            <a:off x="2305050" y="1428750"/>
+            <a:ext cx="342900" cy="781050"/>
           </a:xfrm>
           <a:prstGeom xmlns:a="http://schemas.openxmlformats.org/drawingml/2006/main" prst="rect">
             <a:avLst/>
@@ -1857,7 +1857,7 @@
           <a:lstStyle xmlns:a="http://schemas.openxmlformats.org/drawingml/2006/main"/>
           <a:p xmlns:a="http://schemas.openxmlformats.org/drawingml/2006/main">
             <a:pPr>
-              <a:defRPr sz="1125" b="1">
+              <a:defRPr sz="1050" b="1">
                 <a:solidFill>
                   <a:srgbClr val="172B3A"/>
                 </a:solidFill>
@@ -1867,7 +1867,7 @@
               </a:defRPr>
             </a:pPr>
             <a:r>
-              <a:rPr sz="1125" b="1">
+              <a:rPr sz="1050" b="1">
                 <a:solidFill>
                   <a:srgbClr val="172B3A"/>
                 </a:solidFill>
@@ -1885,19 +1885,19 @@
           <p:cNvPr id="16" name="">
             <a:extLst xmlns:a="http://schemas.openxmlformats.org/drawingml/2006/main">
               <a:ext uri="{FF2B5EF4-FFF2-40B4-BE49-F238E27FC236}">
-                <a16:creationId xmlns:a16="http://schemas.microsoft.com/office/drawing/2014/main" id="{7CA9FE88-9810-40C4-A833-27B5114597D2}"/>
-              </a:ext>
-            </a:extLst>
-          </p:cNvPr>
-          <p:cNvSpPr>
-            <a:spLocks xmlns:a="http://schemas.openxmlformats.org/drawingml/2006/main" noGrp="1"/>
-          </p:cNvSpPr>
-          <p:nvPr/>
-        </p:nvSpPr>
-        <p:spPr>
-          <a:xfrm xmlns:a="http://schemas.openxmlformats.org/drawingml/2006/main">
-            <a:off x="2857500" y="4953000"/>
-            <a:ext cx="857250" cy="857250"/>
+                <a16:creationId xmlns:a16="http://schemas.microsoft.com/office/drawing/2014/main" id="{B1ED9D98-5DE7-4A92-AB14-6AB6D7A31F49}"/>
+              </a:ext>
+            </a:extLst>
+          </p:cNvPr>
+          <p:cNvSpPr>
+            <a:spLocks xmlns:a="http://schemas.openxmlformats.org/drawingml/2006/main" noGrp="1"/>
+          </p:cNvSpPr>
+          <p:nvPr/>
+        </p:nvSpPr>
+        <p:spPr>
+          <a:xfrm xmlns:a="http://schemas.openxmlformats.org/drawingml/2006/main">
+            <a:off x="2714625" y="4552950"/>
+            <a:ext cx="781050" cy="781050"/>
           </a:xfrm>
           <a:prstGeom xmlns:a="http://schemas.openxmlformats.org/drawingml/2006/main" prst="rect">
             <a:avLst/>
@@ -1946,19 +1946,19 @@
           <p:cNvPr id="17" name="">
             <a:extLst xmlns:a="http://schemas.openxmlformats.org/drawingml/2006/main">
               <a:ext uri="{FF2B5EF4-FFF2-40B4-BE49-F238E27FC236}">
-                <a16:creationId xmlns:a16="http://schemas.microsoft.com/office/drawing/2014/main" id="{41A46FBD-C3EA-45A7-82F3-A2B9D549BADC}"/>
-              </a:ext>
-            </a:extLst>
-          </p:cNvPr>
-          <p:cNvSpPr>
-            <a:spLocks xmlns:a="http://schemas.openxmlformats.org/drawingml/2006/main" noGrp="1"/>
-          </p:cNvSpPr>
-          <p:nvPr/>
-        </p:nvSpPr>
-        <p:spPr>
-          <a:xfrm xmlns:a="http://schemas.openxmlformats.org/drawingml/2006/main">
-            <a:off x="2857500" y="4095750"/>
-            <a:ext cx="857250" cy="857250"/>
+                <a16:creationId xmlns:a16="http://schemas.microsoft.com/office/drawing/2014/main" id="{1D7DEABF-6162-4F91-8EE7-DC719116D995}"/>
+              </a:ext>
+            </a:extLst>
+          </p:cNvPr>
+          <p:cNvSpPr>
+            <a:spLocks xmlns:a="http://schemas.openxmlformats.org/drawingml/2006/main" noGrp="1"/>
+          </p:cNvSpPr>
+          <p:nvPr/>
+        </p:nvSpPr>
+        <p:spPr>
+          <a:xfrm xmlns:a="http://schemas.openxmlformats.org/drawingml/2006/main">
+            <a:off x="2714625" y="3771900"/>
+            <a:ext cx="781050" cy="781050"/>
           </a:xfrm>
           <a:prstGeom xmlns:a="http://schemas.openxmlformats.org/drawingml/2006/main" prst="rect">
             <a:avLst/>
@@ -2007,19 +2007,19 @@
           <p:cNvPr id="18" name="">
             <a:extLst xmlns:a="http://schemas.openxmlformats.org/drawingml/2006/main">
               <a:ext uri="{FF2B5EF4-FFF2-40B4-BE49-F238E27FC236}">
-                <a16:creationId xmlns:a16="http://schemas.microsoft.com/office/drawing/2014/main" id="{A1DC3051-F67E-4E01-9994-6BF6AC6F94DF}"/>
-              </a:ext>
-            </a:extLst>
-          </p:cNvPr>
-          <p:cNvSpPr>
-            <a:spLocks xmlns:a="http://schemas.openxmlformats.org/drawingml/2006/main" noGrp="1"/>
-          </p:cNvSpPr>
-          <p:nvPr/>
-        </p:nvSpPr>
-        <p:spPr>
-          <a:xfrm xmlns:a="http://schemas.openxmlformats.org/drawingml/2006/main">
-            <a:off x="2857500" y="3238500"/>
-            <a:ext cx="857250" cy="857250"/>
+                <a16:creationId xmlns:a16="http://schemas.microsoft.com/office/drawing/2014/main" id="{1D58E8AF-CAC4-4E86-99E2-E3500371111E}"/>
+              </a:ext>
+            </a:extLst>
+          </p:cNvPr>
+          <p:cNvSpPr>
+            <a:spLocks xmlns:a="http://schemas.openxmlformats.org/drawingml/2006/main" noGrp="1"/>
+          </p:cNvSpPr>
+          <p:nvPr/>
+        </p:nvSpPr>
+        <p:spPr>
+          <a:xfrm xmlns:a="http://schemas.openxmlformats.org/drawingml/2006/main">
+            <a:off x="2714625" y="2990850"/>
+            <a:ext cx="781050" cy="781050"/>
           </a:xfrm>
           <a:prstGeom xmlns:a="http://schemas.openxmlformats.org/drawingml/2006/main" prst="rect">
             <a:avLst/>
@@ -2068,19 +2068,19 @@
           <p:cNvPr id="19" name="">
             <a:extLst xmlns:a="http://schemas.openxmlformats.org/drawingml/2006/main">
               <a:ext uri="{FF2B5EF4-FFF2-40B4-BE49-F238E27FC236}">
-                <a16:creationId xmlns:a16="http://schemas.microsoft.com/office/drawing/2014/main" id="{DC725F10-10C6-4FE5-90EC-DAEF2118E847}"/>
-              </a:ext>
-            </a:extLst>
-          </p:cNvPr>
-          <p:cNvSpPr>
-            <a:spLocks xmlns:a="http://schemas.openxmlformats.org/drawingml/2006/main" noGrp="1"/>
-          </p:cNvSpPr>
-          <p:nvPr/>
-        </p:nvSpPr>
-        <p:spPr>
-          <a:xfrm xmlns:a="http://schemas.openxmlformats.org/drawingml/2006/main">
-            <a:off x="2857500" y="2381250"/>
-            <a:ext cx="857250" cy="857250"/>
+                <a16:creationId xmlns:a16="http://schemas.microsoft.com/office/drawing/2014/main" id="{44D6012A-2127-495A-8C4E-AC8C5498EB43}"/>
+              </a:ext>
+            </a:extLst>
+          </p:cNvPr>
+          <p:cNvSpPr>
+            <a:spLocks xmlns:a="http://schemas.openxmlformats.org/drawingml/2006/main" noGrp="1"/>
+          </p:cNvSpPr>
+          <p:nvPr/>
+        </p:nvSpPr>
+        <p:spPr>
+          <a:xfrm xmlns:a="http://schemas.openxmlformats.org/drawingml/2006/main">
+            <a:off x="2714625" y="2209800"/>
+            <a:ext cx="781050" cy="781050"/>
           </a:xfrm>
           <a:prstGeom xmlns:a="http://schemas.openxmlformats.org/drawingml/2006/main" prst="rect">
             <a:avLst/>
@@ -2129,19 +2129,19 @@
           <p:cNvPr id="20" name="">
             <a:extLst xmlns:a="http://schemas.openxmlformats.org/drawingml/2006/main">
               <a:ext uri="{FF2B5EF4-FFF2-40B4-BE49-F238E27FC236}">
-                <a16:creationId xmlns:a16="http://schemas.microsoft.com/office/drawing/2014/main" id="{BD9FCBC4-F52D-4CF4-BDD1-10D00D7E8CAB}"/>
-              </a:ext>
-            </a:extLst>
-          </p:cNvPr>
-          <p:cNvSpPr>
-            <a:spLocks xmlns:a="http://schemas.openxmlformats.org/drawingml/2006/main" noGrp="1"/>
-          </p:cNvSpPr>
-          <p:nvPr/>
-        </p:nvSpPr>
-        <p:spPr>
-          <a:xfrm xmlns:a="http://schemas.openxmlformats.org/drawingml/2006/main">
-            <a:off x="2857500" y="1524000"/>
-            <a:ext cx="857250" cy="857250"/>
+                <a16:creationId xmlns:a16="http://schemas.microsoft.com/office/drawing/2014/main" id="{92656921-8D06-41A8-A750-49C54D762218}"/>
+              </a:ext>
+            </a:extLst>
+          </p:cNvPr>
+          <p:cNvSpPr>
+            <a:spLocks xmlns:a="http://schemas.openxmlformats.org/drawingml/2006/main" noGrp="1"/>
+          </p:cNvSpPr>
+          <p:nvPr/>
+        </p:nvSpPr>
+        <p:spPr>
+          <a:xfrm xmlns:a="http://schemas.openxmlformats.org/drawingml/2006/main">
+            <a:off x="2714625" y="1428750"/>
+            <a:ext cx="781050" cy="781050"/>
           </a:xfrm>
           <a:prstGeom xmlns:a="http://schemas.openxmlformats.org/drawingml/2006/main" prst="rect">
             <a:avLst/>
@@ -2190,19 +2190,19 @@
           <p:cNvPr id="21" name="">
             <a:extLst xmlns:a="http://schemas.openxmlformats.org/drawingml/2006/main">
               <a:ext uri="{FF2B5EF4-FFF2-40B4-BE49-F238E27FC236}">
-                <a16:creationId xmlns:a16="http://schemas.microsoft.com/office/drawing/2014/main" id="{450E5092-B704-420C-869D-21440386981E}"/>
-              </a:ext>
-            </a:extLst>
-          </p:cNvPr>
-          <p:cNvSpPr>
-            <a:spLocks xmlns:a="http://schemas.openxmlformats.org/drawingml/2006/main" noGrp="1"/>
-          </p:cNvSpPr>
-          <p:nvPr/>
-        </p:nvSpPr>
-        <p:spPr>
-          <a:xfrm xmlns:a="http://schemas.openxmlformats.org/drawingml/2006/main">
-            <a:off x="3714750" y="4953000"/>
-            <a:ext cx="857250" cy="857250"/>
+                <a16:creationId xmlns:a16="http://schemas.microsoft.com/office/drawing/2014/main" id="{0D3C4E66-CB84-48F8-96DD-520EC2FFE7B2}"/>
+              </a:ext>
+            </a:extLst>
+          </p:cNvPr>
+          <p:cNvSpPr>
+            <a:spLocks xmlns:a="http://schemas.openxmlformats.org/drawingml/2006/main" noGrp="1"/>
+          </p:cNvSpPr>
+          <p:nvPr/>
+        </p:nvSpPr>
+        <p:spPr>
+          <a:xfrm xmlns:a="http://schemas.openxmlformats.org/drawingml/2006/main">
+            <a:off x="3495675" y="4552950"/>
+            <a:ext cx="781050" cy="781050"/>
           </a:xfrm>
           <a:prstGeom xmlns:a="http://schemas.openxmlformats.org/drawingml/2006/main" prst="rect">
             <a:avLst/>
@@ -2251,19 +2251,19 @@
           <p:cNvPr id="22" name="">
             <a:extLst xmlns:a="http://schemas.openxmlformats.org/drawingml/2006/main">
               <a:ext uri="{FF2B5EF4-FFF2-40B4-BE49-F238E27FC236}">
-                <a16:creationId xmlns:a16="http://schemas.microsoft.com/office/drawing/2014/main" id="{FC4A50C4-9134-458F-AAB1-0E555921E51C}"/>
-              </a:ext>
-            </a:extLst>
-          </p:cNvPr>
-          <p:cNvSpPr>
-            <a:spLocks xmlns:a="http://schemas.openxmlformats.org/drawingml/2006/main" noGrp="1"/>
-          </p:cNvSpPr>
-          <p:nvPr/>
-        </p:nvSpPr>
-        <p:spPr>
-          <a:xfrm xmlns:a="http://schemas.openxmlformats.org/drawingml/2006/main">
-            <a:off x="3714750" y="4095750"/>
-            <a:ext cx="857250" cy="857250"/>
+                <a16:creationId xmlns:a16="http://schemas.microsoft.com/office/drawing/2014/main" id="{844450F8-3A8E-4A0D-BC6E-E771C4AFF7D9}"/>
+              </a:ext>
+            </a:extLst>
+          </p:cNvPr>
+          <p:cNvSpPr>
+            <a:spLocks xmlns:a="http://schemas.openxmlformats.org/drawingml/2006/main" noGrp="1"/>
+          </p:cNvSpPr>
+          <p:nvPr/>
+        </p:nvSpPr>
+        <p:spPr>
+          <a:xfrm xmlns:a="http://schemas.openxmlformats.org/drawingml/2006/main">
+            <a:off x="3495675" y="3771900"/>
+            <a:ext cx="781050" cy="781050"/>
           </a:xfrm>
           <a:prstGeom xmlns:a="http://schemas.openxmlformats.org/drawingml/2006/main" prst="rect">
             <a:avLst/>
@@ -2312,19 +2312,19 @@
           <p:cNvPr id="23" name="">
             <a:extLst xmlns:a="http://schemas.openxmlformats.org/drawingml/2006/main">
               <a:ext uri="{FF2B5EF4-FFF2-40B4-BE49-F238E27FC236}">
-                <a16:creationId xmlns:a16="http://schemas.microsoft.com/office/drawing/2014/main" id="{E77B7686-FC6F-410D-99A2-C684FE39177E}"/>
-              </a:ext>
-            </a:extLst>
-          </p:cNvPr>
-          <p:cNvSpPr>
-            <a:spLocks xmlns:a="http://schemas.openxmlformats.org/drawingml/2006/main" noGrp="1"/>
-          </p:cNvSpPr>
-          <p:nvPr/>
-        </p:nvSpPr>
-        <p:spPr>
-          <a:xfrm xmlns:a="http://schemas.openxmlformats.org/drawingml/2006/main">
-            <a:off x="3714750" y="3238500"/>
-            <a:ext cx="857250" cy="857250"/>
+                <a16:creationId xmlns:a16="http://schemas.microsoft.com/office/drawing/2014/main" id="{C5F7EBFB-0326-4D36-918B-32D24E5791F1}"/>
+              </a:ext>
+            </a:extLst>
+          </p:cNvPr>
+          <p:cNvSpPr>
+            <a:spLocks xmlns:a="http://schemas.openxmlformats.org/drawingml/2006/main" noGrp="1"/>
+          </p:cNvSpPr>
+          <p:nvPr/>
+        </p:nvSpPr>
+        <p:spPr>
+          <a:xfrm xmlns:a="http://schemas.openxmlformats.org/drawingml/2006/main">
+            <a:off x="3495675" y="2990850"/>
+            <a:ext cx="781050" cy="781050"/>
           </a:xfrm>
           <a:prstGeom xmlns:a="http://schemas.openxmlformats.org/drawingml/2006/main" prst="rect">
             <a:avLst/>
@@ -2373,19 +2373,19 @@
           <p:cNvPr id="24" name="">
             <a:extLst xmlns:a="http://schemas.openxmlformats.org/drawingml/2006/main">
               <a:ext uri="{FF2B5EF4-FFF2-40B4-BE49-F238E27FC236}">
-                <a16:creationId xmlns:a16="http://schemas.microsoft.com/office/drawing/2014/main" id="{2C1FF815-1CC6-45BE-B0B6-91DDF2052F74}"/>
-              </a:ext>
-            </a:extLst>
-          </p:cNvPr>
-          <p:cNvSpPr>
-            <a:spLocks xmlns:a="http://schemas.openxmlformats.org/drawingml/2006/main" noGrp="1"/>
-          </p:cNvSpPr>
-          <p:nvPr/>
-        </p:nvSpPr>
-        <p:spPr>
-          <a:xfrm xmlns:a="http://schemas.openxmlformats.org/drawingml/2006/main">
-            <a:off x="3714750" y="2381250"/>
-            <a:ext cx="857250" cy="857250"/>
+                <a16:creationId xmlns:a16="http://schemas.microsoft.com/office/drawing/2014/main" id="{E76052AA-2F4C-4170-A3AF-AD4742A6B93D}"/>
+              </a:ext>
+            </a:extLst>
+          </p:cNvPr>
+          <p:cNvSpPr>
+            <a:spLocks xmlns:a="http://schemas.openxmlformats.org/drawingml/2006/main" noGrp="1"/>
+          </p:cNvSpPr>
+          <p:nvPr/>
+        </p:nvSpPr>
+        <p:spPr>
+          <a:xfrm xmlns:a="http://schemas.openxmlformats.org/drawingml/2006/main">
+            <a:off x="3495675" y="2209800"/>
+            <a:ext cx="781050" cy="781050"/>
           </a:xfrm>
           <a:prstGeom xmlns:a="http://schemas.openxmlformats.org/drawingml/2006/main" prst="rect">
             <a:avLst/>
@@ -2434,19 +2434,19 @@
           <p:cNvPr id="25" name="">
             <a:extLst xmlns:a="http://schemas.openxmlformats.org/drawingml/2006/main">
               <a:ext uri="{FF2B5EF4-FFF2-40B4-BE49-F238E27FC236}">
-                <a16:creationId xmlns:a16="http://schemas.microsoft.com/office/drawing/2014/main" id="{48B01BEF-51E0-4EB5-BA83-AD2903032D0C}"/>
-              </a:ext>
-            </a:extLst>
-          </p:cNvPr>
-          <p:cNvSpPr>
-            <a:spLocks xmlns:a="http://schemas.openxmlformats.org/drawingml/2006/main" noGrp="1"/>
-          </p:cNvSpPr>
-          <p:nvPr/>
-        </p:nvSpPr>
-        <p:spPr>
-          <a:xfrm xmlns:a="http://schemas.openxmlformats.org/drawingml/2006/main">
-            <a:off x="3714750" y="1524000"/>
-            <a:ext cx="857250" cy="857250"/>
+                <a16:creationId xmlns:a16="http://schemas.microsoft.com/office/drawing/2014/main" id="{E6A92399-B0F7-4FDA-99BA-779C53C1CB77}"/>
+              </a:ext>
+            </a:extLst>
+          </p:cNvPr>
+          <p:cNvSpPr>
+            <a:spLocks xmlns:a="http://schemas.openxmlformats.org/drawingml/2006/main" noGrp="1"/>
+          </p:cNvSpPr>
+          <p:nvPr/>
+        </p:nvSpPr>
+        <p:spPr>
+          <a:xfrm xmlns:a="http://schemas.openxmlformats.org/drawingml/2006/main">
+            <a:off x="3495675" y="1428750"/>
+            <a:ext cx="781050" cy="781050"/>
           </a:xfrm>
           <a:prstGeom xmlns:a="http://schemas.openxmlformats.org/drawingml/2006/main" prst="rect">
             <a:avLst/>
@@ -2495,19 +2495,19 @@
           <p:cNvPr id="26" name="">
             <a:extLst xmlns:a="http://schemas.openxmlformats.org/drawingml/2006/main">
               <a:ext uri="{FF2B5EF4-FFF2-40B4-BE49-F238E27FC236}">
-                <a16:creationId xmlns:a16="http://schemas.microsoft.com/office/drawing/2014/main" id="{454A8BC7-BC22-46EF-99DB-E3AAE13003C2}"/>
-              </a:ext>
-            </a:extLst>
-          </p:cNvPr>
-          <p:cNvSpPr>
-            <a:spLocks xmlns:a="http://schemas.openxmlformats.org/drawingml/2006/main" noGrp="1"/>
-          </p:cNvSpPr>
-          <p:nvPr/>
-        </p:nvSpPr>
-        <p:spPr>
-          <a:xfrm xmlns:a="http://schemas.openxmlformats.org/drawingml/2006/main">
-            <a:off x="4572000" y="4953000"/>
-            <a:ext cx="857250" cy="857250"/>
+                <a16:creationId xmlns:a16="http://schemas.microsoft.com/office/drawing/2014/main" id="{4365D9E1-FC86-49DA-BA55-3C80D27A86DD}"/>
+              </a:ext>
+            </a:extLst>
+          </p:cNvPr>
+          <p:cNvSpPr>
+            <a:spLocks xmlns:a="http://schemas.openxmlformats.org/drawingml/2006/main" noGrp="1"/>
+          </p:cNvSpPr>
+          <p:nvPr/>
+        </p:nvSpPr>
+        <p:spPr>
+          <a:xfrm xmlns:a="http://schemas.openxmlformats.org/drawingml/2006/main">
+            <a:off x="4276725" y="4552950"/>
+            <a:ext cx="781050" cy="781050"/>
           </a:xfrm>
           <a:prstGeom xmlns:a="http://schemas.openxmlformats.org/drawingml/2006/main" prst="rect">
             <a:avLst/>
@@ -2556,19 +2556,19 @@
           <p:cNvPr id="27" name="">
             <a:extLst xmlns:a="http://schemas.openxmlformats.org/drawingml/2006/main">
               <a:ext uri="{FF2B5EF4-FFF2-40B4-BE49-F238E27FC236}">
-                <a16:creationId xmlns:a16="http://schemas.microsoft.com/office/drawing/2014/main" id="{0AE2794F-F2D2-4822-A623-5363F81A3322}"/>
-              </a:ext>
-            </a:extLst>
-          </p:cNvPr>
-          <p:cNvSpPr>
-            <a:spLocks xmlns:a="http://schemas.openxmlformats.org/drawingml/2006/main" noGrp="1"/>
-          </p:cNvSpPr>
-          <p:nvPr/>
-        </p:nvSpPr>
-        <p:spPr>
-          <a:xfrm xmlns:a="http://schemas.openxmlformats.org/drawingml/2006/main">
-            <a:off x="4572000" y="4095750"/>
-            <a:ext cx="857250" cy="857250"/>
+                <a16:creationId xmlns:a16="http://schemas.microsoft.com/office/drawing/2014/main" id="{DFF95E56-5154-4CD6-85CD-59A2038AEE23}"/>
+              </a:ext>
+            </a:extLst>
+          </p:cNvPr>
+          <p:cNvSpPr>
+            <a:spLocks xmlns:a="http://schemas.openxmlformats.org/drawingml/2006/main" noGrp="1"/>
+          </p:cNvSpPr>
+          <p:nvPr/>
+        </p:nvSpPr>
+        <p:spPr>
+          <a:xfrm xmlns:a="http://schemas.openxmlformats.org/drawingml/2006/main">
+            <a:off x="4276725" y="3771900"/>
+            <a:ext cx="781050" cy="781050"/>
           </a:xfrm>
           <a:prstGeom xmlns:a="http://schemas.openxmlformats.org/drawingml/2006/main" prst="rect">
             <a:avLst/>
@@ -2617,19 +2617,19 @@
           <p:cNvPr id="28" name="">
             <a:extLst xmlns:a="http://schemas.openxmlformats.org/drawingml/2006/main">
               <a:ext uri="{FF2B5EF4-FFF2-40B4-BE49-F238E27FC236}">
-                <a16:creationId xmlns:a16="http://schemas.microsoft.com/office/drawing/2014/main" id="{35644554-02D3-42C8-9783-7B513911120B}"/>
-              </a:ext>
-            </a:extLst>
-          </p:cNvPr>
-          <p:cNvSpPr>
-            <a:spLocks xmlns:a="http://schemas.openxmlformats.org/drawingml/2006/main" noGrp="1"/>
-          </p:cNvSpPr>
-          <p:nvPr/>
-        </p:nvSpPr>
-        <p:spPr>
-          <a:xfrm xmlns:a="http://schemas.openxmlformats.org/drawingml/2006/main">
-            <a:off x="4572000" y="3238500"/>
-            <a:ext cx="857250" cy="857250"/>
+                <a16:creationId xmlns:a16="http://schemas.microsoft.com/office/drawing/2014/main" id="{50EF6AA4-EBAB-4D74-8AE4-FB60E1B2DF51}"/>
+              </a:ext>
+            </a:extLst>
+          </p:cNvPr>
+          <p:cNvSpPr>
+            <a:spLocks xmlns:a="http://schemas.openxmlformats.org/drawingml/2006/main" noGrp="1"/>
+          </p:cNvSpPr>
+          <p:nvPr/>
+        </p:nvSpPr>
+        <p:spPr>
+          <a:xfrm xmlns:a="http://schemas.openxmlformats.org/drawingml/2006/main">
+            <a:off x="4276725" y="2990850"/>
+            <a:ext cx="781050" cy="781050"/>
           </a:xfrm>
           <a:prstGeom xmlns:a="http://schemas.openxmlformats.org/drawingml/2006/main" prst="rect">
             <a:avLst/>
@@ -2678,19 +2678,19 @@
           <p:cNvPr id="29" name="">
             <a:extLst xmlns:a="http://schemas.openxmlformats.org/drawingml/2006/main">
               <a:ext uri="{FF2B5EF4-FFF2-40B4-BE49-F238E27FC236}">
-                <a16:creationId xmlns:a16="http://schemas.microsoft.com/office/drawing/2014/main" id="{F6BA377F-C211-409E-9CFB-FF65D9E3C9D6}"/>
-              </a:ext>
-            </a:extLst>
-          </p:cNvPr>
-          <p:cNvSpPr>
-            <a:spLocks xmlns:a="http://schemas.openxmlformats.org/drawingml/2006/main" noGrp="1"/>
-          </p:cNvSpPr>
-          <p:nvPr/>
-        </p:nvSpPr>
-        <p:spPr>
-          <a:xfrm xmlns:a="http://schemas.openxmlformats.org/drawingml/2006/main">
-            <a:off x="4572000" y="2381250"/>
-            <a:ext cx="857250" cy="857250"/>
+                <a16:creationId xmlns:a16="http://schemas.microsoft.com/office/drawing/2014/main" id="{E98D592D-186F-4C1A-A16F-5E445D44D1A4}"/>
+              </a:ext>
+            </a:extLst>
+          </p:cNvPr>
+          <p:cNvSpPr>
+            <a:spLocks xmlns:a="http://schemas.openxmlformats.org/drawingml/2006/main" noGrp="1"/>
+          </p:cNvSpPr>
+          <p:nvPr/>
+        </p:nvSpPr>
+        <p:spPr>
+          <a:xfrm xmlns:a="http://schemas.openxmlformats.org/drawingml/2006/main">
+            <a:off x="4276725" y="2209800"/>
+            <a:ext cx="781050" cy="781050"/>
           </a:xfrm>
           <a:prstGeom xmlns:a="http://schemas.openxmlformats.org/drawingml/2006/main" prst="rect">
             <a:avLst/>
@@ -2739,19 +2739,19 @@
           <p:cNvPr id="30" name="">
             <a:extLst xmlns:a="http://schemas.openxmlformats.org/drawingml/2006/main">
               <a:ext uri="{FF2B5EF4-FFF2-40B4-BE49-F238E27FC236}">
-                <a16:creationId xmlns:a16="http://schemas.microsoft.com/office/drawing/2014/main" id="{BBB729D4-FF8B-4B36-8EEB-0DA3E8EC5F5C}"/>
-              </a:ext>
-            </a:extLst>
-          </p:cNvPr>
-          <p:cNvSpPr>
-            <a:spLocks xmlns:a="http://schemas.openxmlformats.org/drawingml/2006/main" noGrp="1"/>
-          </p:cNvSpPr>
-          <p:nvPr/>
-        </p:nvSpPr>
-        <p:spPr>
-          <a:xfrm xmlns:a="http://schemas.openxmlformats.org/drawingml/2006/main">
-            <a:off x="4572000" y="1524000"/>
-            <a:ext cx="857250" cy="857250"/>
+                <a16:creationId xmlns:a16="http://schemas.microsoft.com/office/drawing/2014/main" id="{4CE605C2-83E9-471D-9E46-D9A856CF93A5}"/>
+              </a:ext>
+            </a:extLst>
+          </p:cNvPr>
+          <p:cNvSpPr>
+            <a:spLocks xmlns:a="http://schemas.openxmlformats.org/drawingml/2006/main" noGrp="1"/>
+          </p:cNvSpPr>
+          <p:nvPr/>
+        </p:nvSpPr>
+        <p:spPr>
+          <a:xfrm xmlns:a="http://schemas.openxmlformats.org/drawingml/2006/main">
+            <a:off x="4276725" y="1428750"/>
+            <a:ext cx="781050" cy="781050"/>
           </a:xfrm>
           <a:prstGeom xmlns:a="http://schemas.openxmlformats.org/drawingml/2006/main" prst="rect">
             <a:avLst/>
@@ -2800,19 +2800,19 @@
           <p:cNvPr id="31" name="">
             <a:extLst xmlns:a="http://schemas.openxmlformats.org/drawingml/2006/main">
               <a:ext uri="{FF2B5EF4-FFF2-40B4-BE49-F238E27FC236}">
-                <a16:creationId xmlns:a16="http://schemas.microsoft.com/office/drawing/2014/main" id="{FB5FA5F6-1CEB-4D69-A28C-B732E3990B41}"/>
-              </a:ext>
-            </a:extLst>
-          </p:cNvPr>
-          <p:cNvSpPr>
-            <a:spLocks xmlns:a="http://schemas.openxmlformats.org/drawingml/2006/main" noGrp="1"/>
-          </p:cNvSpPr>
-          <p:nvPr/>
-        </p:nvSpPr>
-        <p:spPr>
-          <a:xfrm xmlns:a="http://schemas.openxmlformats.org/drawingml/2006/main">
-            <a:off x="5429250" y="4953000"/>
-            <a:ext cx="857250" cy="857250"/>
+                <a16:creationId xmlns:a16="http://schemas.microsoft.com/office/drawing/2014/main" id="{81AA6645-1950-4B07-BFA2-D0B5D8963C1E}"/>
+              </a:ext>
+            </a:extLst>
+          </p:cNvPr>
+          <p:cNvSpPr>
+            <a:spLocks xmlns:a="http://schemas.openxmlformats.org/drawingml/2006/main" noGrp="1"/>
+          </p:cNvSpPr>
+          <p:nvPr/>
+        </p:nvSpPr>
+        <p:spPr>
+          <a:xfrm xmlns:a="http://schemas.openxmlformats.org/drawingml/2006/main">
+            <a:off x="5057775" y="4552950"/>
+            <a:ext cx="781050" cy="781050"/>
           </a:xfrm>
           <a:prstGeom xmlns:a="http://schemas.openxmlformats.org/drawingml/2006/main" prst="rect">
             <a:avLst/>
@@ -2861,19 +2861,19 @@
           <p:cNvPr id="32" name="">
             <a:extLst xmlns:a="http://schemas.openxmlformats.org/drawingml/2006/main">
               <a:ext uri="{FF2B5EF4-FFF2-40B4-BE49-F238E27FC236}">
-                <a16:creationId xmlns:a16="http://schemas.microsoft.com/office/drawing/2014/main" id="{AC75202A-9732-47F7-B892-FF12D01E083F}"/>
-              </a:ext>
-            </a:extLst>
-          </p:cNvPr>
-          <p:cNvSpPr>
-            <a:spLocks xmlns:a="http://schemas.openxmlformats.org/drawingml/2006/main" noGrp="1"/>
-          </p:cNvSpPr>
-          <p:nvPr/>
-        </p:nvSpPr>
-        <p:spPr>
-          <a:xfrm xmlns:a="http://schemas.openxmlformats.org/drawingml/2006/main">
-            <a:off x="5429250" y="4095750"/>
-            <a:ext cx="857250" cy="857250"/>
+                <a16:creationId xmlns:a16="http://schemas.microsoft.com/office/drawing/2014/main" id="{8668B473-D073-4F82-9C15-21E560EBEFEE}"/>
+              </a:ext>
+            </a:extLst>
+          </p:cNvPr>
+          <p:cNvSpPr>
+            <a:spLocks xmlns:a="http://schemas.openxmlformats.org/drawingml/2006/main" noGrp="1"/>
+          </p:cNvSpPr>
+          <p:nvPr/>
+        </p:nvSpPr>
+        <p:spPr>
+          <a:xfrm xmlns:a="http://schemas.openxmlformats.org/drawingml/2006/main">
+            <a:off x="5057775" y="3771900"/>
+            <a:ext cx="781050" cy="781050"/>
           </a:xfrm>
           <a:prstGeom xmlns:a="http://schemas.openxmlformats.org/drawingml/2006/main" prst="rect">
             <a:avLst/>
@@ -2922,19 +2922,19 @@
           <p:cNvPr id="33" name="">
             <a:extLst xmlns:a="http://schemas.openxmlformats.org/drawingml/2006/main">
               <a:ext uri="{FF2B5EF4-FFF2-40B4-BE49-F238E27FC236}">
-                <a16:creationId xmlns:a16="http://schemas.microsoft.com/office/drawing/2014/main" id="{3B60B62C-2A86-4305-B7E3-A79C41FC67BC}"/>
-              </a:ext>
-            </a:extLst>
-          </p:cNvPr>
-          <p:cNvSpPr>
-            <a:spLocks xmlns:a="http://schemas.openxmlformats.org/drawingml/2006/main" noGrp="1"/>
-          </p:cNvSpPr>
-          <p:nvPr/>
-        </p:nvSpPr>
-        <p:spPr>
-          <a:xfrm xmlns:a="http://schemas.openxmlformats.org/drawingml/2006/main">
-            <a:off x="5429250" y="3238500"/>
-            <a:ext cx="857250" cy="857250"/>
+                <a16:creationId xmlns:a16="http://schemas.microsoft.com/office/drawing/2014/main" id="{34CD0652-BC00-4B4E-BB88-43D2732A49C8}"/>
+              </a:ext>
+            </a:extLst>
+          </p:cNvPr>
+          <p:cNvSpPr>
+            <a:spLocks xmlns:a="http://schemas.openxmlformats.org/drawingml/2006/main" noGrp="1"/>
+          </p:cNvSpPr>
+          <p:nvPr/>
+        </p:nvSpPr>
+        <p:spPr>
+          <a:xfrm xmlns:a="http://schemas.openxmlformats.org/drawingml/2006/main">
+            <a:off x="5057775" y="2990850"/>
+            <a:ext cx="781050" cy="781050"/>
           </a:xfrm>
           <a:prstGeom xmlns:a="http://schemas.openxmlformats.org/drawingml/2006/main" prst="rect">
             <a:avLst/>
@@ -2983,19 +2983,19 @@
           <p:cNvPr id="34" name="">
             <a:extLst xmlns:a="http://schemas.openxmlformats.org/drawingml/2006/main">
               <a:ext uri="{FF2B5EF4-FFF2-40B4-BE49-F238E27FC236}">
-                <a16:creationId xmlns:a16="http://schemas.microsoft.com/office/drawing/2014/main" id="{45EE8D73-6D34-4239-BFC1-83369E0F2545}"/>
-              </a:ext>
-            </a:extLst>
-          </p:cNvPr>
-          <p:cNvSpPr>
-            <a:spLocks xmlns:a="http://schemas.openxmlformats.org/drawingml/2006/main" noGrp="1"/>
-          </p:cNvSpPr>
-          <p:nvPr/>
-        </p:nvSpPr>
-        <p:spPr>
-          <a:xfrm xmlns:a="http://schemas.openxmlformats.org/drawingml/2006/main">
-            <a:off x="5429250" y="2381250"/>
-            <a:ext cx="857250" cy="857250"/>
+                <a16:creationId xmlns:a16="http://schemas.microsoft.com/office/drawing/2014/main" id="{A1D493A7-A187-416F-96F4-3E946AE7CE64}"/>
+              </a:ext>
+            </a:extLst>
+          </p:cNvPr>
+          <p:cNvSpPr>
+            <a:spLocks xmlns:a="http://schemas.openxmlformats.org/drawingml/2006/main" noGrp="1"/>
+          </p:cNvSpPr>
+          <p:nvPr/>
+        </p:nvSpPr>
+        <p:spPr>
+          <a:xfrm xmlns:a="http://schemas.openxmlformats.org/drawingml/2006/main">
+            <a:off x="5057775" y="2209800"/>
+            <a:ext cx="781050" cy="781050"/>
           </a:xfrm>
           <a:prstGeom xmlns:a="http://schemas.openxmlformats.org/drawingml/2006/main" prst="rect">
             <a:avLst/>
@@ -3044,19 +3044,19 @@
           <p:cNvPr id="35" name="">
             <a:extLst xmlns:a="http://schemas.openxmlformats.org/drawingml/2006/main">
               <a:ext uri="{FF2B5EF4-FFF2-40B4-BE49-F238E27FC236}">
-                <a16:creationId xmlns:a16="http://schemas.microsoft.com/office/drawing/2014/main" id="{74ADA215-B2C6-4169-9B6A-56B822206697}"/>
-              </a:ext>
-            </a:extLst>
-          </p:cNvPr>
-          <p:cNvSpPr>
-            <a:spLocks xmlns:a="http://schemas.openxmlformats.org/drawingml/2006/main" noGrp="1"/>
-          </p:cNvSpPr>
-          <p:nvPr/>
-        </p:nvSpPr>
-        <p:spPr>
-          <a:xfrm xmlns:a="http://schemas.openxmlformats.org/drawingml/2006/main">
-            <a:off x="5429250" y="1524000"/>
-            <a:ext cx="857250" cy="857250"/>
+                <a16:creationId xmlns:a16="http://schemas.microsoft.com/office/drawing/2014/main" id="{8A94EDFE-7062-4775-AE28-5AE7F6267580}"/>
+              </a:ext>
+            </a:extLst>
+          </p:cNvPr>
+          <p:cNvSpPr>
+            <a:spLocks xmlns:a="http://schemas.openxmlformats.org/drawingml/2006/main" noGrp="1"/>
+          </p:cNvSpPr>
+          <p:nvPr/>
+        </p:nvSpPr>
+        <p:spPr>
+          <a:xfrm xmlns:a="http://schemas.openxmlformats.org/drawingml/2006/main">
+            <a:off x="5057775" y="1428750"/>
+            <a:ext cx="781050" cy="781050"/>
           </a:xfrm>
           <a:prstGeom xmlns:a="http://schemas.openxmlformats.org/drawingml/2006/main" prst="rect">
             <a:avLst/>
@@ -3105,19 +3105,19 @@
           <p:cNvPr id="36" name="">
             <a:extLst xmlns:a="http://schemas.openxmlformats.org/drawingml/2006/main">
               <a:ext uri="{FF2B5EF4-FFF2-40B4-BE49-F238E27FC236}">
-                <a16:creationId xmlns:a16="http://schemas.microsoft.com/office/drawing/2014/main" id="{6C27C940-6149-4F17-8FA1-0298C63045D1}"/>
-              </a:ext>
-            </a:extLst>
-          </p:cNvPr>
-          <p:cNvSpPr>
-            <a:spLocks xmlns:a="http://schemas.openxmlformats.org/drawingml/2006/main" noGrp="1"/>
-          </p:cNvSpPr>
-          <p:nvPr/>
-        </p:nvSpPr>
-        <p:spPr>
-          <a:xfrm xmlns:a="http://schemas.openxmlformats.org/drawingml/2006/main">
-            <a:off x="6286500" y="4953000"/>
-            <a:ext cx="857250" cy="857250"/>
+                <a16:creationId xmlns:a16="http://schemas.microsoft.com/office/drawing/2014/main" id="{556B2587-D9B5-4EC5-AB05-5687CDB1E4FB}"/>
+              </a:ext>
+            </a:extLst>
+          </p:cNvPr>
+          <p:cNvSpPr>
+            <a:spLocks xmlns:a="http://schemas.openxmlformats.org/drawingml/2006/main" noGrp="1"/>
+          </p:cNvSpPr>
+          <p:nvPr/>
+        </p:nvSpPr>
+        <p:spPr>
+          <a:xfrm xmlns:a="http://schemas.openxmlformats.org/drawingml/2006/main">
+            <a:off x="5838825" y="4552950"/>
+            <a:ext cx="781050" cy="781050"/>
           </a:xfrm>
           <a:prstGeom xmlns:a="http://schemas.openxmlformats.org/drawingml/2006/main" prst="rect">
             <a:avLst/>
@@ -3166,19 +3166,19 @@
           <p:cNvPr id="37" name="">
             <a:extLst xmlns:a="http://schemas.openxmlformats.org/drawingml/2006/main">
               <a:ext uri="{FF2B5EF4-FFF2-40B4-BE49-F238E27FC236}">
-                <a16:creationId xmlns:a16="http://schemas.microsoft.com/office/drawing/2014/main" id="{75CAD750-CB61-4E6D-BB95-F933130F404D}"/>
-              </a:ext>
-            </a:extLst>
-          </p:cNvPr>
-          <p:cNvSpPr>
-            <a:spLocks xmlns:a="http://schemas.openxmlformats.org/drawingml/2006/main" noGrp="1"/>
-          </p:cNvSpPr>
-          <p:nvPr/>
-        </p:nvSpPr>
-        <p:spPr>
-          <a:xfrm xmlns:a="http://schemas.openxmlformats.org/drawingml/2006/main">
-            <a:off x="6286500" y="4095750"/>
-            <a:ext cx="857250" cy="857250"/>
+                <a16:creationId xmlns:a16="http://schemas.microsoft.com/office/drawing/2014/main" id="{84433DFD-4042-4C14-8B2B-376CC699C806}"/>
+              </a:ext>
+            </a:extLst>
+          </p:cNvPr>
+          <p:cNvSpPr>
+            <a:spLocks xmlns:a="http://schemas.openxmlformats.org/drawingml/2006/main" noGrp="1"/>
+          </p:cNvSpPr>
+          <p:nvPr/>
+        </p:nvSpPr>
+        <p:spPr>
+          <a:xfrm xmlns:a="http://schemas.openxmlformats.org/drawingml/2006/main">
+            <a:off x="5838825" y="3771900"/>
+            <a:ext cx="781050" cy="781050"/>
           </a:xfrm>
           <a:prstGeom xmlns:a="http://schemas.openxmlformats.org/drawingml/2006/main" prst="rect">
             <a:avLst/>
@@ -3227,19 +3227,19 @@
           <p:cNvPr id="38" name="">
             <a:extLst xmlns:a="http://schemas.openxmlformats.org/drawingml/2006/main">
               <a:ext uri="{FF2B5EF4-FFF2-40B4-BE49-F238E27FC236}">
-                <a16:creationId xmlns:a16="http://schemas.microsoft.com/office/drawing/2014/main" id="{85E96489-C7AE-4737-8B72-5BDADF5F9C40}"/>
-              </a:ext>
-            </a:extLst>
-          </p:cNvPr>
-          <p:cNvSpPr>
-            <a:spLocks xmlns:a="http://schemas.openxmlformats.org/drawingml/2006/main" noGrp="1"/>
-          </p:cNvSpPr>
-          <p:nvPr/>
-        </p:nvSpPr>
-        <p:spPr>
-          <a:xfrm xmlns:a="http://schemas.openxmlformats.org/drawingml/2006/main">
-            <a:off x="6286500" y="3238500"/>
-            <a:ext cx="857250" cy="857250"/>
+                <a16:creationId xmlns:a16="http://schemas.microsoft.com/office/drawing/2014/main" id="{156C1CC9-253B-4E71-B70B-C3C374B85515}"/>
+              </a:ext>
+            </a:extLst>
+          </p:cNvPr>
+          <p:cNvSpPr>
+            <a:spLocks xmlns:a="http://schemas.openxmlformats.org/drawingml/2006/main" noGrp="1"/>
+          </p:cNvSpPr>
+          <p:nvPr/>
+        </p:nvSpPr>
+        <p:spPr>
+          <a:xfrm xmlns:a="http://schemas.openxmlformats.org/drawingml/2006/main">
+            <a:off x="5838825" y="2990850"/>
+            <a:ext cx="781050" cy="781050"/>
           </a:xfrm>
           <a:prstGeom xmlns:a="http://schemas.openxmlformats.org/drawingml/2006/main" prst="rect">
             <a:avLst/>
@@ -3288,19 +3288,19 @@
           <p:cNvPr id="39" name="">
             <a:extLst xmlns:a="http://schemas.openxmlformats.org/drawingml/2006/main">
               <a:ext uri="{FF2B5EF4-FFF2-40B4-BE49-F238E27FC236}">
-                <a16:creationId xmlns:a16="http://schemas.microsoft.com/office/drawing/2014/main" id="{56D57028-95EB-4063-B392-518EF14B71CF}"/>
-              </a:ext>
-            </a:extLst>
-          </p:cNvPr>
-          <p:cNvSpPr>
-            <a:spLocks xmlns:a="http://schemas.openxmlformats.org/drawingml/2006/main" noGrp="1"/>
-          </p:cNvSpPr>
-          <p:nvPr/>
-        </p:nvSpPr>
-        <p:spPr>
-          <a:xfrm xmlns:a="http://schemas.openxmlformats.org/drawingml/2006/main">
-            <a:off x="6286500" y="2381250"/>
-            <a:ext cx="857250" cy="857250"/>
+                <a16:creationId xmlns:a16="http://schemas.microsoft.com/office/drawing/2014/main" id="{786D6CBC-9176-40C5-BFC9-180EC982B430}"/>
+              </a:ext>
+            </a:extLst>
+          </p:cNvPr>
+          <p:cNvSpPr>
+            <a:spLocks xmlns:a="http://schemas.openxmlformats.org/drawingml/2006/main" noGrp="1"/>
+          </p:cNvSpPr>
+          <p:nvPr/>
+        </p:nvSpPr>
+        <p:spPr>
+          <a:xfrm xmlns:a="http://schemas.openxmlformats.org/drawingml/2006/main">
+            <a:off x="5838825" y="2209800"/>
+            <a:ext cx="781050" cy="781050"/>
           </a:xfrm>
           <a:prstGeom xmlns:a="http://schemas.openxmlformats.org/drawingml/2006/main" prst="rect">
             <a:avLst/>
@@ -3349,19 +3349,19 @@
           <p:cNvPr id="40" name="">
             <a:extLst xmlns:a="http://schemas.openxmlformats.org/drawingml/2006/main">
               <a:ext uri="{FF2B5EF4-FFF2-40B4-BE49-F238E27FC236}">
-                <a16:creationId xmlns:a16="http://schemas.microsoft.com/office/drawing/2014/main" id="{5BA908D6-1045-414C-9C47-FE57072E9B3E}"/>
-              </a:ext>
-            </a:extLst>
-          </p:cNvPr>
-          <p:cNvSpPr>
-            <a:spLocks xmlns:a="http://schemas.openxmlformats.org/drawingml/2006/main" noGrp="1"/>
-          </p:cNvSpPr>
-          <p:nvPr/>
-        </p:nvSpPr>
-        <p:spPr>
-          <a:xfrm xmlns:a="http://schemas.openxmlformats.org/drawingml/2006/main">
-            <a:off x="6286500" y="1524000"/>
-            <a:ext cx="857250" cy="857250"/>
+                <a16:creationId xmlns:a16="http://schemas.microsoft.com/office/drawing/2014/main" id="{EFFB016D-25F3-42AF-AE81-AE029575AAAC}"/>
+              </a:ext>
+            </a:extLst>
+          </p:cNvPr>
+          <p:cNvSpPr>
+            <a:spLocks xmlns:a="http://schemas.openxmlformats.org/drawingml/2006/main" noGrp="1"/>
+          </p:cNvSpPr>
+          <p:nvPr/>
+        </p:nvSpPr>
+        <p:spPr>
+          <a:xfrm xmlns:a="http://schemas.openxmlformats.org/drawingml/2006/main">
+            <a:off x="5838825" y="1428750"/>
+            <a:ext cx="781050" cy="781050"/>
           </a:xfrm>
           <a:prstGeom xmlns:a="http://schemas.openxmlformats.org/drawingml/2006/main" prst="rect">
             <a:avLst/>
@@ -3410,23 +3410,23 @@
           <p:cNvPr id="41" name="">
             <a:extLst xmlns:a="http://schemas.openxmlformats.org/drawingml/2006/main">
               <a:ext uri="{FF2B5EF4-FFF2-40B4-BE49-F238E27FC236}">
-                <a16:creationId xmlns:a16="http://schemas.microsoft.com/office/drawing/2014/main" id="{96CE29FD-5673-4CDD-8B64-05D3EB0DBCFD}"/>
-              </a:ext>
-            </a:extLst>
-          </p:cNvPr>
-          <p:cNvSpPr>
-            <a:spLocks xmlns:a="http://schemas.openxmlformats.org/drawingml/2006/main" noGrp="1"/>
-          </p:cNvSpPr>
-          <p:nvPr/>
-        </p:nvSpPr>
-        <p:spPr>
-          <a:xfrm xmlns:a="http://schemas.openxmlformats.org/drawingml/2006/main">
-            <a:off x="5476875" y="1571625"/>
-            <a:ext cx="371475" cy="190500"/>
+                <a16:creationId xmlns:a16="http://schemas.microsoft.com/office/drawing/2014/main" id="{90E491E8-1F23-4740-9551-FE72C0F52965}"/>
+              </a:ext>
+            </a:extLst>
+          </p:cNvPr>
+          <p:cNvSpPr>
+            <a:spLocks xmlns:a="http://schemas.openxmlformats.org/drawingml/2006/main" noGrp="1"/>
+          </p:cNvSpPr>
+          <p:nvPr/>
+        </p:nvSpPr>
+        <p:spPr>
+          <a:xfrm xmlns:a="http://schemas.openxmlformats.org/drawingml/2006/main">
+            <a:off x="5095875" y="1476375"/>
+            <a:ext cx="333375" cy="180975"/>
           </a:xfrm>
           <a:prstGeom xmlns:a="http://schemas.openxmlformats.org/drawingml/2006/main" prst="roundRect">
             <a:avLst>
-              <a:gd name="adj" fmla="val 40000"/>
+              <a:gd name="adj" fmla="val 42105"/>
             </a:avLst>
           </a:prstGeom>
           <a:solidFill xmlns:a="http://schemas.openxmlformats.org/drawingml/2006/main">
@@ -3440,12 +3440,12 @@
         </p:spPr>
         <p:txBody>
           <a:bodyPr xmlns:a="http://schemas.openxmlformats.org/drawingml/2006/main" anchor="ctr">
-            <a:normAutofit fontScale="45318"/>
-          </a:bodyPr>
-          <a:lstStyle xmlns:a="http://schemas.openxmlformats.org/drawingml/2006/main"/>
-          <a:p xmlns:a="http://schemas.openxmlformats.org/drawingml/2006/main">
-            <a:pPr>
-              <a:defRPr sz="788" b="1">
+            <a:normAutofit fontScale="40083"/>
+          </a:bodyPr>
+          <a:lstStyle xmlns:a="http://schemas.openxmlformats.org/drawingml/2006/main"/>
+          <a:p xmlns:a="http://schemas.openxmlformats.org/drawingml/2006/main">
+            <a:pPr>
+              <a:defRPr sz="735" b="1">
                 <a:solidFill>
                   <a:srgbClr val="FFFFFF"/>
                 </a:solidFill>
@@ -3455,7 +3455,7 @@
               </a:defRPr>
             </a:pPr>
             <a:r>
-              <a:rPr sz="788" b="1">
+              <a:rPr sz="735" b="1">
                 <a:solidFill>
                   <a:srgbClr val="FFFFFF"/>
                 </a:solidFill>
@@ -3473,23 +3473,23 @@
           <p:cNvPr id="42" name="">
             <a:extLst xmlns:a="http://schemas.openxmlformats.org/drawingml/2006/main">
               <a:ext uri="{FF2B5EF4-FFF2-40B4-BE49-F238E27FC236}">
-                <a16:creationId xmlns:a16="http://schemas.microsoft.com/office/drawing/2014/main" id="{73353DCC-3ED0-4B37-925F-6427D8CC01C0}"/>
-              </a:ext>
-            </a:extLst>
-          </p:cNvPr>
-          <p:cNvSpPr>
-            <a:spLocks xmlns:a="http://schemas.openxmlformats.org/drawingml/2006/main" noGrp="1"/>
-          </p:cNvSpPr>
-          <p:nvPr/>
-        </p:nvSpPr>
-        <p:spPr>
-          <a:xfrm xmlns:a="http://schemas.openxmlformats.org/drawingml/2006/main">
-            <a:off x="4619625" y="1571625"/>
-            <a:ext cx="371475" cy="190500"/>
+                <a16:creationId xmlns:a16="http://schemas.microsoft.com/office/drawing/2014/main" id="{6607C58B-6A37-49A5-A747-96A82A7FCB4A}"/>
+              </a:ext>
+            </a:extLst>
+          </p:cNvPr>
+          <p:cNvSpPr>
+            <a:spLocks xmlns:a="http://schemas.openxmlformats.org/drawingml/2006/main" noGrp="1"/>
+          </p:cNvSpPr>
+          <p:nvPr/>
+        </p:nvSpPr>
+        <p:spPr>
+          <a:xfrm xmlns:a="http://schemas.openxmlformats.org/drawingml/2006/main">
+            <a:off x="4314825" y="1476375"/>
+            <a:ext cx="333375" cy="180975"/>
           </a:xfrm>
           <a:prstGeom xmlns:a="http://schemas.openxmlformats.org/drawingml/2006/main" prst="roundRect">
             <a:avLst>
-              <a:gd name="adj" fmla="val 40000"/>
+              <a:gd name="adj" fmla="val 42105"/>
             </a:avLst>
           </a:prstGeom>
           <a:solidFill xmlns:a="http://schemas.openxmlformats.org/drawingml/2006/main">
@@ -3503,12 +3503,12 @@
         </p:spPr>
         <p:txBody>
           <a:bodyPr xmlns:a="http://schemas.openxmlformats.org/drawingml/2006/main" anchor="ctr">
-            <a:normAutofit fontScale="45318"/>
-          </a:bodyPr>
-          <a:lstStyle xmlns:a="http://schemas.openxmlformats.org/drawingml/2006/main"/>
-          <a:p xmlns:a="http://schemas.openxmlformats.org/drawingml/2006/main">
-            <a:pPr>
-              <a:defRPr sz="788" b="1">
+            <a:normAutofit fontScale="40083"/>
+          </a:bodyPr>
+          <a:lstStyle xmlns:a="http://schemas.openxmlformats.org/drawingml/2006/main"/>
+          <a:p xmlns:a="http://schemas.openxmlformats.org/drawingml/2006/main">
+            <a:pPr>
+              <a:defRPr sz="735" b="1">
                 <a:solidFill>
                   <a:srgbClr val="FFFFFF"/>
                 </a:solidFill>
@@ -3518,7 +3518,7 @@
               </a:defRPr>
             </a:pPr>
             <a:r>
-              <a:rPr sz="788" b="1">
+              <a:rPr sz="735" b="1">
                 <a:solidFill>
                   <a:srgbClr val="FFFFFF"/>
                 </a:solidFill>
@@ -3536,23 +3536,23 @@
           <p:cNvPr id="43" name="">
             <a:extLst xmlns:a="http://schemas.openxmlformats.org/drawingml/2006/main">
               <a:ext uri="{FF2B5EF4-FFF2-40B4-BE49-F238E27FC236}">
-                <a16:creationId xmlns:a16="http://schemas.microsoft.com/office/drawing/2014/main" id="{4FA005BE-21BC-4B40-8C52-9AEFA9EBF170}"/>
-              </a:ext>
-            </a:extLst>
-          </p:cNvPr>
-          <p:cNvSpPr>
-            <a:spLocks xmlns:a="http://schemas.openxmlformats.org/drawingml/2006/main" noGrp="1"/>
-          </p:cNvSpPr>
-          <p:nvPr/>
-        </p:nvSpPr>
-        <p:spPr>
-          <a:xfrm xmlns:a="http://schemas.openxmlformats.org/drawingml/2006/main">
-            <a:off x="5476875" y="2428875"/>
-            <a:ext cx="371475" cy="190500"/>
+                <a16:creationId xmlns:a16="http://schemas.microsoft.com/office/drawing/2014/main" id="{7597B0EB-6D4A-43C3-A944-073EE7BFA00A}"/>
+              </a:ext>
+            </a:extLst>
+          </p:cNvPr>
+          <p:cNvSpPr>
+            <a:spLocks xmlns:a="http://schemas.openxmlformats.org/drawingml/2006/main" noGrp="1"/>
+          </p:cNvSpPr>
+          <p:nvPr/>
+        </p:nvSpPr>
+        <p:spPr>
+          <a:xfrm xmlns:a="http://schemas.openxmlformats.org/drawingml/2006/main">
+            <a:off x="5095875" y="2257425"/>
+            <a:ext cx="333375" cy="180975"/>
           </a:xfrm>
           <a:prstGeom xmlns:a="http://schemas.openxmlformats.org/drawingml/2006/main" prst="roundRect">
             <a:avLst>
-              <a:gd name="adj" fmla="val 40000"/>
+              <a:gd name="adj" fmla="val 42105"/>
             </a:avLst>
           </a:prstGeom>
           <a:solidFill xmlns:a="http://schemas.openxmlformats.org/drawingml/2006/main">
@@ -3566,12 +3566,12 @@
         </p:spPr>
         <p:txBody>
           <a:bodyPr xmlns:a="http://schemas.openxmlformats.org/drawingml/2006/main" anchor="ctr">
-            <a:normAutofit fontScale="45318"/>
-          </a:bodyPr>
-          <a:lstStyle xmlns:a="http://schemas.openxmlformats.org/drawingml/2006/main"/>
-          <a:p xmlns:a="http://schemas.openxmlformats.org/drawingml/2006/main">
-            <a:pPr>
-              <a:defRPr sz="788" b="1">
+            <a:normAutofit fontScale="40083"/>
+          </a:bodyPr>
+          <a:lstStyle xmlns:a="http://schemas.openxmlformats.org/drawingml/2006/main"/>
+          <a:p xmlns:a="http://schemas.openxmlformats.org/drawingml/2006/main">
+            <a:pPr>
+              <a:defRPr sz="735" b="1">
                 <a:solidFill>
                   <a:srgbClr val="FFFFFF"/>
                 </a:solidFill>
@@ -3581,7 +3581,7 @@
               </a:defRPr>
             </a:pPr>
             <a:r>
-              <a:rPr sz="788" b="1">
+              <a:rPr sz="735" b="1">
                 <a:solidFill>
                   <a:srgbClr val="FFFFFF"/>
                 </a:solidFill>
@@ -3599,23 +3599,23 @@
           <p:cNvPr id="44" name="">
             <a:extLst xmlns:a="http://schemas.openxmlformats.org/drawingml/2006/main">
               <a:ext uri="{FF2B5EF4-FFF2-40B4-BE49-F238E27FC236}">
-                <a16:creationId xmlns:a16="http://schemas.microsoft.com/office/drawing/2014/main" id="{14CB6E87-5999-44E9-973E-DBC76263143F}"/>
-              </a:ext>
-            </a:extLst>
-          </p:cNvPr>
-          <p:cNvSpPr>
-            <a:spLocks xmlns:a="http://schemas.openxmlformats.org/drawingml/2006/main" noGrp="1"/>
-          </p:cNvSpPr>
-          <p:nvPr/>
-        </p:nvSpPr>
-        <p:spPr>
-          <a:xfrm xmlns:a="http://schemas.openxmlformats.org/drawingml/2006/main">
-            <a:off x="4619625" y="2428875"/>
-            <a:ext cx="371475" cy="190500"/>
+                <a16:creationId xmlns:a16="http://schemas.microsoft.com/office/drawing/2014/main" id="{7BFF2C2D-FC63-4502-BF80-C05FB3743CB2}"/>
+              </a:ext>
+            </a:extLst>
+          </p:cNvPr>
+          <p:cNvSpPr>
+            <a:spLocks xmlns:a="http://schemas.openxmlformats.org/drawingml/2006/main" noGrp="1"/>
+          </p:cNvSpPr>
+          <p:nvPr/>
+        </p:nvSpPr>
+        <p:spPr>
+          <a:xfrm xmlns:a="http://schemas.openxmlformats.org/drawingml/2006/main">
+            <a:off x="4314825" y="2257425"/>
+            <a:ext cx="333375" cy="180975"/>
           </a:xfrm>
           <a:prstGeom xmlns:a="http://schemas.openxmlformats.org/drawingml/2006/main" prst="roundRect">
             <a:avLst>
-              <a:gd name="adj" fmla="val 40000"/>
+              <a:gd name="adj" fmla="val 42105"/>
             </a:avLst>
           </a:prstGeom>
           <a:solidFill xmlns:a="http://schemas.openxmlformats.org/drawingml/2006/main">
@@ -3629,12 +3629,12 @@
         </p:spPr>
         <p:txBody>
           <a:bodyPr xmlns:a="http://schemas.openxmlformats.org/drawingml/2006/main" anchor="ctr">
-            <a:normAutofit fontScale="45318"/>
-          </a:bodyPr>
-          <a:lstStyle xmlns:a="http://schemas.openxmlformats.org/drawingml/2006/main"/>
-          <a:p xmlns:a="http://schemas.openxmlformats.org/drawingml/2006/main">
-            <a:pPr>
-              <a:defRPr sz="788" b="1">
+            <a:normAutofit fontScale="40083"/>
+          </a:bodyPr>
+          <a:lstStyle xmlns:a="http://schemas.openxmlformats.org/drawingml/2006/main"/>
+          <a:p xmlns:a="http://schemas.openxmlformats.org/drawingml/2006/main">
+            <a:pPr>
+              <a:defRPr sz="735" b="1">
                 <a:solidFill>
                   <a:srgbClr val="FFFFFF"/>
                 </a:solidFill>
@@ -3644,7 +3644,7 @@
               </a:defRPr>
             </a:pPr>
             <a:r>
-              <a:rPr sz="788" b="1">
+              <a:rPr sz="735" b="1">
                 <a:solidFill>
                   <a:srgbClr val="FFFFFF"/>
                 </a:solidFill>
@@ -3662,23 +3662,23 @@
           <p:cNvPr id="45" name="">
             <a:extLst xmlns:a="http://schemas.openxmlformats.org/drawingml/2006/main">
               <a:ext uri="{FF2B5EF4-FFF2-40B4-BE49-F238E27FC236}">
-                <a16:creationId xmlns:a16="http://schemas.microsoft.com/office/drawing/2014/main" id="{75B14F3D-4183-46B2-85B9-D6D39D17EC76}"/>
-              </a:ext>
-            </a:extLst>
-          </p:cNvPr>
-          <p:cNvSpPr>
-            <a:spLocks xmlns:a="http://schemas.openxmlformats.org/drawingml/2006/main" noGrp="1"/>
-          </p:cNvSpPr>
-          <p:nvPr/>
-        </p:nvSpPr>
-        <p:spPr>
-          <a:xfrm xmlns:a="http://schemas.openxmlformats.org/drawingml/2006/main">
-            <a:off x="5010150" y="2428875"/>
-            <a:ext cx="371475" cy="190500"/>
+                <a16:creationId xmlns:a16="http://schemas.microsoft.com/office/drawing/2014/main" id="{A204A607-B518-4A78-937B-7466DC242D0F}"/>
+              </a:ext>
+            </a:extLst>
+          </p:cNvPr>
+          <p:cNvSpPr>
+            <a:spLocks xmlns:a="http://schemas.openxmlformats.org/drawingml/2006/main" noGrp="1"/>
+          </p:cNvSpPr>
+          <p:nvPr/>
+        </p:nvSpPr>
+        <p:spPr>
+          <a:xfrm xmlns:a="http://schemas.openxmlformats.org/drawingml/2006/main">
+            <a:off x="4667250" y="2257425"/>
+            <a:ext cx="333375" cy="180975"/>
           </a:xfrm>
           <a:prstGeom xmlns:a="http://schemas.openxmlformats.org/drawingml/2006/main" prst="roundRect">
             <a:avLst>
-              <a:gd name="adj" fmla="val 40000"/>
+              <a:gd name="adj" fmla="val 42105"/>
             </a:avLst>
           </a:prstGeom>
           <a:solidFill xmlns:a="http://schemas.openxmlformats.org/drawingml/2006/main">
@@ -3692,12 +3692,12 @@
         </p:spPr>
         <p:txBody>
           <a:bodyPr xmlns:a="http://schemas.openxmlformats.org/drawingml/2006/main" anchor="ctr">
-            <a:normAutofit fontScale="45318"/>
-          </a:bodyPr>
-          <a:lstStyle xmlns:a="http://schemas.openxmlformats.org/drawingml/2006/main"/>
-          <a:p xmlns:a="http://schemas.openxmlformats.org/drawingml/2006/main">
-            <a:pPr>
-              <a:defRPr sz="788" b="1">
+            <a:normAutofit fontScale="40083"/>
+          </a:bodyPr>
+          <a:lstStyle xmlns:a="http://schemas.openxmlformats.org/drawingml/2006/main"/>
+          <a:p xmlns:a="http://schemas.openxmlformats.org/drawingml/2006/main">
+            <a:pPr>
+              <a:defRPr sz="735" b="1">
                 <a:solidFill>
                   <a:srgbClr val="FFFFFF"/>
                 </a:solidFill>
@@ -3707,7 +3707,7 @@
               </a:defRPr>
             </a:pPr>
             <a:r>
-              <a:rPr sz="788" b="1">
+              <a:rPr sz="735" b="1">
                 <a:solidFill>
                   <a:srgbClr val="FFFFFF"/>
                 </a:solidFill>
@@ -3725,23 +3725,23 @@
           <p:cNvPr id="46" name="">
             <a:extLst xmlns:a="http://schemas.openxmlformats.org/drawingml/2006/main">
               <a:ext uri="{FF2B5EF4-FFF2-40B4-BE49-F238E27FC236}">
-                <a16:creationId xmlns:a16="http://schemas.microsoft.com/office/drawing/2014/main" id="{C06C85A2-CC01-49B4-9977-0E20E2A737AB}"/>
-              </a:ext>
-            </a:extLst>
-          </p:cNvPr>
-          <p:cNvSpPr>
-            <a:spLocks xmlns:a="http://schemas.openxmlformats.org/drawingml/2006/main" noGrp="1"/>
-          </p:cNvSpPr>
-          <p:nvPr/>
-        </p:nvSpPr>
-        <p:spPr>
-          <a:xfrm xmlns:a="http://schemas.openxmlformats.org/drawingml/2006/main">
-            <a:off x="5867400" y="2428875"/>
-            <a:ext cx="371475" cy="190500"/>
+                <a16:creationId xmlns:a16="http://schemas.microsoft.com/office/drawing/2014/main" id="{3847A14D-1D75-42B4-A1C1-60815E403297}"/>
+              </a:ext>
+            </a:extLst>
+          </p:cNvPr>
+          <p:cNvSpPr>
+            <a:spLocks xmlns:a="http://schemas.openxmlformats.org/drawingml/2006/main" noGrp="1"/>
+          </p:cNvSpPr>
+          <p:nvPr/>
+        </p:nvSpPr>
+        <p:spPr>
+          <a:xfrm xmlns:a="http://schemas.openxmlformats.org/drawingml/2006/main">
+            <a:off x="5448300" y="2257425"/>
+            <a:ext cx="333375" cy="180975"/>
           </a:xfrm>
           <a:prstGeom xmlns:a="http://schemas.openxmlformats.org/drawingml/2006/main" prst="roundRect">
             <a:avLst>
-              <a:gd name="adj" fmla="val 40000"/>
+              <a:gd name="adj" fmla="val 42105"/>
             </a:avLst>
           </a:prstGeom>
           <a:solidFill xmlns:a="http://schemas.openxmlformats.org/drawingml/2006/main">
@@ -3755,12 +3755,12 @@
         </p:spPr>
         <p:txBody>
           <a:bodyPr xmlns:a="http://schemas.openxmlformats.org/drawingml/2006/main" anchor="ctr">
-            <a:normAutofit fontScale="45318"/>
-          </a:bodyPr>
-          <a:lstStyle xmlns:a="http://schemas.openxmlformats.org/drawingml/2006/main"/>
-          <a:p xmlns:a="http://schemas.openxmlformats.org/drawingml/2006/main">
-            <a:pPr>
-              <a:defRPr sz="788" b="1">
+            <a:normAutofit fontScale="40083"/>
+          </a:bodyPr>
+          <a:lstStyle xmlns:a="http://schemas.openxmlformats.org/drawingml/2006/main"/>
+          <a:p xmlns:a="http://schemas.openxmlformats.org/drawingml/2006/main">
+            <a:pPr>
+              <a:defRPr sz="735" b="1">
                 <a:solidFill>
                   <a:srgbClr val="FFFFFF"/>
                 </a:solidFill>
@@ -3770,7 +3770,7 @@
               </a:defRPr>
             </a:pPr>
             <a:r>
-              <a:rPr sz="788" b="1">
+              <a:rPr sz="735" b="1">
                 <a:solidFill>
                   <a:srgbClr val="FFFFFF"/>
                 </a:solidFill>
@@ -3788,23 +3788,23 @@
           <p:cNvPr id="47" name="">
             <a:extLst xmlns:a="http://schemas.openxmlformats.org/drawingml/2006/main">
               <a:ext uri="{FF2B5EF4-FFF2-40B4-BE49-F238E27FC236}">
-                <a16:creationId xmlns:a16="http://schemas.microsoft.com/office/drawing/2014/main" id="{15CB8E82-25EF-4B53-88CF-816E1AF1D769}"/>
-              </a:ext>
-            </a:extLst>
-          </p:cNvPr>
-          <p:cNvSpPr>
-            <a:spLocks xmlns:a="http://schemas.openxmlformats.org/drawingml/2006/main" noGrp="1"/>
-          </p:cNvSpPr>
-          <p:nvPr/>
-        </p:nvSpPr>
-        <p:spPr>
-          <a:xfrm xmlns:a="http://schemas.openxmlformats.org/drawingml/2006/main">
-            <a:off x="4619625" y="2657475"/>
-            <a:ext cx="371475" cy="190500"/>
+                <a16:creationId xmlns:a16="http://schemas.microsoft.com/office/drawing/2014/main" id="{1A8D7105-5F27-4CCA-A6C7-A18C70E48390}"/>
+              </a:ext>
+            </a:extLst>
+          </p:cNvPr>
+          <p:cNvSpPr>
+            <a:spLocks xmlns:a="http://schemas.openxmlformats.org/drawingml/2006/main" noGrp="1"/>
+          </p:cNvSpPr>
+          <p:nvPr/>
+        </p:nvSpPr>
+        <p:spPr>
+          <a:xfrm xmlns:a="http://schemas.openxmlformats.org/drawingml/2006/main">
+            <a:off x="4314825" y="2476500"/>
+            <a:ext cx="333375" cy="180975"/>
           </a:xfrm>
           <a:prstGeom xmlns:a="http://schemas.openxmlformats.org/drawingml/2006/main" prst="roundRect">
             <a:avLst>
-              <a:gd name="adj" fmla="val 40000"/>
+              <a:gd name="adj" fmla="val 42105"/>
             </a:avLst>
           </a:prstGeom>
           <a:solidFill xmlns:a="http://schemas.openxmlformats.org/drawingml/2006/main">
@@ -3818,12 +3818,12 @@
         </p:spPr>
         <p:txBody>
           <a:bodyPr xmlns:a="http://schemas.openxmlformats.org/drawingml/2006/main" anchor="ctr">
-            <a:normAutofit fontScale="45318"/>
-          </a:bodyPr>
-          <a:lstStyle xmlns:a="http://schemas.openxmlformats.org/drawingml/2006/main"/>
-          <a:p xmlns:a="http://schemas.openxmlformats.org/drawingml/2006/main">
-            <a:pPr>
-              <a:defRPr sz="788" b="1">
+            <a:normAutofit fontScale="40083"/>
+          </a:bodyPr>
+          <a:lstStyle xmlns:a="http://schemas.openxmlformats.org/drawingml/2006/main"/>
+          <a:p xmlns:a="http://schemas.openxmlformats.org/drawingml/2006/main">
+            <a:pPr>
+              <a:defRPr sz="735" b="1">
                 <a:solidFill>
                   <a:srgbClr val="FFFFFF"/>
                 </a:solidFill>
@@ -3833,7 +3833,7 @@
               </a:defRPr>
             </a:pPr>
             <a:r>
-              <a:rPr sz="788" b="1">
+              <a:rPr sz="735" b="1">
                 <a:solidFill>
                   <a:srgbClr val="FFFFFF"/>
                 </a:solidFill>
@@ -3851,23 +3851,23 @@
           <p:cNvPr id="48" name="">
             <a:extLst xmlns:a="http://schemas.openxmlformats.org/drawingml/2006/main">
               <a:ext uri="{FF2B5EF4-FFF2-40B4-BE49-F238E27FC236}">
-                <a16:creationId xmlns:a16="http://schemas.microsoft.com/office/drawing/2014/main" id="{58935F21-F547-45FC-A28B-BBB27D92EB6F}"/>
-              </a:ext>
-            </a:extLst>
-          </p:cNvPr>
-          <p:cNvSpPr>
-            <a:spLocks xmlns:a="http://schemas.openxmlformats.org/drawingml/2006/main" noGrp="1"/>
-          </p:cNvSpPr>
-          <p:nvPr/>
-        </p:nvSpPr>
-        <p:spPr>
-          <a:xfrm xmlns:a="http://schemas.openxmlformats.org/drawingml/2006/main">
-            <a:off x="5867400" y="1571625"/>
-            <a:ext cx="371475" cy="190500"/>
+                <a16:creationId xmlns:a16="http://schemas.microsoft.com/office/drawing/2014/main" id="{86221A15-9CD4-4115-BE85-2B1B82CB3B4C}"/>
+              </a:ext>
+            </a:extLst>
+          </p:cNvPr>
+          <p:cNvSpPr>
+            <a:spLocks xmlns:a="http://schemas.openxmlformats.org/drawingml/2006/main" noGrp="1"/>
+          </p:cNvSpPr>
+          <p:nvPr/>
+        </p:nvSpPr>
+        <p:spPr>
+          <a:xfrm xmlns:a="http://schemas.openxmlformats.org/drawingml/2006/main">
+            <a:off x="5448300" y="1476375"/>
+            <a:ext cx="333375" cy="180975"/>
           </a:xfrm>
           <a:prstGeom xmlns:a="http://schemas.openxmlformats.org/drawingml/2006/main" prst="roundRect">
             <a:avLst>
-              <a:gd name="adj" fmla="val 40000"/>
+              <a:gd name="adj" fmla="val 42105"/>
             </a:avLst>
           </a:prstGeom>
           <a:solidFill xmlns:a="http://schemas.openxmlformats.org/drawingml/2006/main">
@@ -3881,12 +3881,12 @@
         </p:spPr>
         <p:txBody>
           <a:bodyPr xmlns:a="http://schemas.openxmlformats.org/drawingml/2006/main" anchor="ctr">
-            <a:normAutofit fontScale="45318"/>
-          </a:bodyPr>
-          <a:lstStyle xmlns:a="http://schemas.openxmlformats.org/drawingml/2006/main"/>
-          <a:p xmlns:a="http://schemas.openxmlformats.org/drawingml/2006/main">
-            <a:pPr>
-              <a:defRPr sz="788" b="1">
+            <a:normAutofit fontScale="40083"/>
+          </a:bodyPr>
+          <a:lstStyle xmlns:a="http://schemas.openxmlformats.org/drawingml/2006/main"/>
+          <a:p xmlns:a="http://schemas.openxmlformats.org/drawingml/2006/main">
+            <a:pPr>
+              <a:defRPr sz="735" b="1">
                 <a:solidFill>
                   <a:srgbClr val="FFFFFF"/>
                 </a:solidFill>
@@ -3896,7 +3896,7 @@
               </a:defRPr>
             </a:pPr>
             <a:r>
-              <a:rPr sz="788" b="1">
+              <a:rPr sz="735" b="1">
                 <a:solidFill>
                   <a:srgbClr val="FFFFFF"/>
                 </a:solidFill>
@@ -3914,23 +3914,23 @@
           <p:cNvPr id="49" name="">
             <a:extLst xmlns:a="http://schemas.openxmlformats.org/drawingml/2006/main">
               <a:ext uri="{FF2B5EF4-FFF2-40B4-BE49-F238E27FC236}">
-                <a16:creationId xmlns:a16="http://schemas.microsoft.com/office/drawing/2014/main" id="{8A278096-C948-4078-9CD6-2FF3B1ABED2D}"/>
-              </a:ext>
-            </a:extLst>
-          </p:cNvPr>
-          <p:cNvSpPr>
-            <a:spLocks xmlns:a="http://schemas.openxmlformats.org/drawingml/2006/main" noGrp="1"/>
-          </p:cNvSpPr>
-          <p:nvPr/>
-        </p:nvSpPr>
-        <p:spPr>
-          <a:xfrm xmlns:a="http://schemas.openxmlformats.org/drawingml/2006/main">
-            <a:off x="5010150" y="1571625"/>
-            <a:ext cx="371475" cy="190500"/>
+                <a16:creationId xmlns:a16="http://schemas.microsoft.com/office/drawing/2014/main" id="{70CCB196-CF7C-49EF-ABDB-3F103FA0A7F3}"/>
+              </a:ext>
+            </a:extLst>
+          </p:cNvPr>
+          <p:cNvSpPr>
+            <a:spLocks xmlns:a="http://schemas.openxmlformats.org/drawingml/2006/main" noGrp="1"/>
+          </p:cNvSpPr>
+          <p:nvPr/>
+        </p:nvSpPr>
+        <p:spPr>
+          <a:xfrm xmlns:a="http://schemas.openxmlformats.org/drawingml/2006/main">
+            <a:off x="4667250" y="1476375"/>
+            <a:ext cx="333375" cy="180975"/>
           </a:xfrm>
           <a:prstGeom xmlns:a="http://schemas.openxmlformats.org/drawingml/2006/main" prst="roundRect">
             <a:avLst>
-              <a:gd name="adj" fmla="val 40000"/>
+              <a:gd name="adj" fmla="val 42105"/>
             </a:avLst>
           </a:prstGeom>
           <a:solidFill xmlns:a="http://schemas.openxmlformats.org/drawingml/2006/main">
@@ -3944,12 +3944,12 @@
         </p:spPr>
         <p:txBody>
           <a:bodyPr xmlns:a="http://schemas.openxmlformats.org/drawingml/2006/main" anchor="ctr">
-            <a:normAutofit fontScale="45318"/>
-          </a:bodyPr>
-          <a:lstStyle xmlns:a="http://schemas.openxmlformats.org/drawingml/2006/main"/>
-          <a:p xmlns:a="http://schemas.openxmlformats.org/drawingml/2006/main">
-            <a:pPr>
-              <a:defRPr sz="788" b="1">
+            <a:normAutofit fontScale="40083"/>
+          </a:bodyPr>
+          <a:lstStyle xmlns:a="http://schemas.openxmlformats.org/drawingml/2006/main"/>
+          <a:p xmlns:a="http://schemas.openxmlformats.org/drawingml/2006/main">
+            <a:pPr>
+              <a:defRPr sz="735" b="1">
                 <a:solidFill>
                   <a:srgbClr val="FFFFFF"/>
                 </a:solidFill>
@@ -3959,7 +3959,7 @@
               </a:defRPr>
             </a:pPr>
             <a:r>
-              <a:rPr sz="788" b="1">
+              <a:rPr sz="735" b="1">
                 <a:solidFill>
                   <a:srgbClr val="FFFFFF"/>
                 </a:solidFill>
@@ -3977,23 +3977,23 @@
           <p:cNvPr id="50" name="">
             <a:extLst xmlns:a="http://schemas.openxmlformats.org/drawingml/2006/main">
               <a:ext uri="{FF2B5EF4-FFF2-40B4-BE49-F238E27FC236}">
-                <a16:creationId xmlns:a16="http://schemas.microsoft.com/office/drawing/2014/main" id="{D1AEA3D7-98A2-47D9-8F80-632BA05988D6}"/>
-              </a:ext>
-            </a:extLst>
-          </p:cNvPr>
-          <p:cNvSpPr>
-            <a:spLocks xmlns:a="http://schemas.openxmlformats.org/drawingml/2006/main" noGrp="1"/>
-          </p:cNvSpPr>
-          <p:nvPr/>
-        </p:nvSpPr>
-        <p:spPr>
-          <a:xfrm xmlns:a="http://schemas.openxmlformats.org/drawingml/2006/main">
-            <a:off x="5476875" y="1800225"/>
-            <a:ext cx="371475" cy="190500"/>
+                <a16:creationId xmlns:a16="http://schemas.microsoft.com/office/drawing/2014/main" id="{47093F98-9CA6-422F-8E64-A35DF925ECF4}"/>
+              </a:ext>
+            </a:extLst>
+          </p:cNvPr>
+          <p:cNvSpPr>
+            <a:spLocks xmlns:a="http://schemas.openxmlformats.org/drawingml/2006/main" noGrp="1"/>
+          </p:cNvSpPr>
+          <p:nvPr/>
+        </p:nvSpPr>
+        <p:spPr>
+          <a:xfrm xmlns:a="http://schemas.openxmlformats.org/drawingml/2006/main">
+            <a:off x="5095875" y="1695450"/>
+            <a:ext cx="333375" cy="180975"/>
           </a:xfrm>
           <a:prstGeom xmlns:a="http://schemas.openxmlformats.org/drawingml/2006/main" prst="roundRect">
             <a:avLst>
-              <a:gd name="adj" fmla="val 40000"/>
+              <a:gd name="adj" fmla="val 42105"/>
             </a:avLst>
           </a:prstGeom>
           <a:solidFill xmlns:a="http://schemas.openxmlformats.org/drawingml/2006/main">
@@ -4007,12 +4007,12 @@
         </p:spPr>
         <p:txBody>
           <a:bodyPr xmlns:a="http://schemas.openxmlformats.org/drawingml/2006/main" anchor="ctr">
-            <a:normAutofit fontScale="45318"/>
-          </a:bodyPr>
-          <a:lstStyle xmlns:a="http://schemas.openxmlformats.org/drawingml/2006/main"/>
-          <a:p xmlns:a="http://schemas.openxmlformats.org/drawingml/2006/main">
-            <a:pPr>
-              <a:defRPr sz="788" b="1">
+            <a:normAutofit fontScale="40083"/>
+          </a:bodyPr>
+          <a:lstStyle xmlns:a="http://schemas.openxmlformats.org/drawingml/2006/main"/>
+          <a:p xmlns:a="http://schemas.openxmlformats.org/drawingml/2006/main">
+            <a:pPr>
+              <a:defRPr sz="735" b="1">
                 <a:solidFill>
                   <a:srgbClr val="FFFFFF"/>
                 </a:solidFill>
@@ -4022,7 +4022,7 @@
               </a:defRPr>
             </a:pPr>
             <a:r>
-              <a:rPr sz="788" b="1">
+              <a:rPr sz="735" b="1">
                 <a:solidFill>
                   <a:srgbClr val="FFFFFF"/>
                 </a:solidFill>
@@ -4040,23 +4040,23 @@
           <p:cNvPr id="51" name="">
             <a:extLst xmlns:a="http://schemas.openxmlformats.org/drawingml/2006/main">
               <a:ext uri="{FF2B5EF4-FFF2-40B4-BE49-F238E27FC236}">
-                <a16:creationId xmlns:a16="http://schemas.microsoft.com/office/drawing/2014/main" id="{0F944C29-3E46-4002-B2CC-6D9CC39ED34F}"/>
-              </a:ext>
-            </a:extLst>
-          </p:cNvPr>
-          <p:cNvSpPr>
-            <a:spLocks xmlns:a="http://schemas.openxmlformats.org/drawingml/2006/main" noGrp="1"/>
-          </p:cNvSpPr>
-          <p:nvPr/>
-        </p:nvSpPr>
-        <p:spPr>
-          <a:xfrm xmlns:a="http://schemas.openxmlformats.org/drawingml/2006/main">
-            <a:off x="4619625" y="1800225"/>
-            <a:ext cx="371475" cy="190500"/>
+                <a16:creationId xmlns:a16="http://schemas.microsoft.com/office/drawing/2014/main" id="{9DEA1F77-08A5-4CDB-A071-3CE344F9CF7A}"/>
+              </a:ext>
+            </a:extLst>
+          </p:cNvPr>
+          <p:cNvSpPr>
+            <a:spLocks xmlns:a="http://schemas.openxmlformats.org/drawingml/2006/main" noGrp="1"/>
+          </p:cNvSpPr>
+          <p:nvPr/>
+        </p:nvSpPr>
+        <p:spPr>
+          <a:xfrm xmlns:a="http://schemas.openxmlformats.org/drawingml/2006/main">
+            <a:off x="4314825" y="1695450"/>
+            <a:ext cx="333375" cy="180975"/>
           </a:xfrm>
           <a:prstGeom xmlns:a="http://schemas.openxmlformats.org/drawingml/2006/main" prst="roundRect">
             <a:avLst>
-              <a:gd name="adj" fmla="val 40000"/>
+              <a:gd name="adj" fmla="val 42105"/>
             </a:avLst>
           </a:prstGeom>
           <a:solidFill xmlns:a="http://schemas.openxmlformats.org/drawingml/2006/main">
@@ -4070,12 +4070,12 @@
         </p:spPr>
         <p:txBody>
           <a:bodyPr xmlns:a="http://schemas.openxmlformats.org/drawingml/2006/main" anchor="ctr">
-            <a:normAutofit fontScale="45318"/>
-          </a:bodyPr>
-          <a:lstStyle xmlns:a="http://schemas.openxmlformats.org/drawingml/2006/main"/>
-          <a:p xmlns:a="http://schemas.openxmlformats.org/drawingml/2006/main">
-            <a:pPr>
-              <a:defRPr sz="788" b="1">
+            <a:normAutofit fontScale="40083"/>
+          </a:bodyPr>
+          <a:lstStyle xmlns:a="http://schemas.openxmlformats.org/drawingml/2006/main"/>
+          <a:p xmlns:a="http://schemas.openxmlformats.org/drawingml/2006/main">
+            <a:pPr>
+              <a:defRPr sz="735" b="1">
                 <a:solidFill>
                   <a:srgbClr val="FFFFFF"/>
                 </a:solidFill>
@@ -4085,7 +4085,7 @@
               </a:defRPr>
             </a:pPr>
             <a:r>
-              <a:rPr sz="788" b="1">
+              <a:rPr sz="735" b="1">
                 <a:solidFill>
                   <a:srgbClr val="FFFFFF"/>
                 </a:solidFill>
@@ -4103,23 +4103,23 @@
           <p:cNvPr id="52" name="">
             <a:extLst xmlns:a="http://schemas.openxmlformats.org/drawingml/2006/main">
               <a:ext uri="{FF2B5EF4-FFF2-40B4-BE49-F238E27FC236}">
-                <a16:creationId xmlns:a16="http://schemas.microsoft.com/office/drawing/2014/main" id="{139D5950-BFD9-462C-942E-334E67DD5189}"/>
-              </a:ext>
-            </a:extLst>
-          </p:cNvPr>
-          <p:cNvSpPr>
-            <a:spLocks xmlns:a="http://schemas.openxmlformats.org/drawingml/2006/main" noGrp="1"/>
-          </p:cNvSpPr>
-          <p:nvPr/>
-        </p:nvSpPr>
-        <p:spPr>
-          <a:xfrm xmlns:a="http://schemas.openxmlformats.org/drawingml/2006/main">
-            <a:off x="5010150" y="2657475"/>
-            <a:ext cx="371475" cy="190500"/>
+                <a16:creationId xmlns:a16="http://schemas.microsoft.com/office/drawing/2014/main" id="{D1882EA9-8545-4D22-ACF2-16BB93EE46D3}"/>
+              </a:ext>
+            </a:extLst>
+          </p:cNvPr>
+          <p:cNvSpPr>
+            <a:spLocks xmlns:a="http://schemas.openxmlformats.org/drawingml/2006/main" noGrp="1"/>
+          </p:cNvSpPr>
+          <p:nvPr/>
+        </p:nvSpPr>
+        <p:spPr>
+          <a:xfrm xmlns:a="http://schemas.openxmlformats.org/drawingml/2006/main">
+            <a:off x="4667250" y="2476500"/>
+            <a:ext cx="333375" cy="180975"/>
           </a:xfrm>
           <a:prstGeom xmlns:a="http://schemas.openxmlformats.org/drawingml/2006/main" prst="roundRect">
             <a:avLst>
-              <a:gd name="adj" fmla="val 40000"/>
+              <a:gd name="adj" fmla="val 42105"/>
             </a:avLst>
           </a:prstGeom>
           <a:solidFill xmlns:a="http://schemas.openxmlformats.org/drawingml/2006/main">
@@ -4133,12 +4133,12 @@
         </p:spPr>
         <p:txBody>
           <a:bodyPr xmlns:a="http://schemas.openxmlformats.org/drawingml/2006/main" anchor="ctr">
-            <a:normAutofit fontScale="45318"/>
-          </a:bodyPr>
-          <a:lstStyle xmlns:a="http://schemas.openxmlformats.org/drawingml/2006/main"/>
-          <a:p xmlns:a="http://schemas.openxmlformats.org/drawingml/2006/main">
-            <a:pPr>
-              <a:defRPr sz="788" b="1">
+            <a:normAutofit fontScale="40083"/>
+          </a:bodyPr>
+          <a:lstStyle xmlns:a="http://schemas.openxmlformats.org/drawingml/2006/main"/>
+          <a:p xmlns:a="http://schemas.openxmlformats.org/drawingml/2006/main">
+            <a:pPr>
+              <a:defRPr sz="735" b="1">
                 <a:solidFill>
                   <a:srgbClr val="FFFFFF"/>
                 </a:solidFill>
@@ -4148,7 +4148,7 @@
               </a:defRPr>
             </a:pPr>
             <a:r>
-              <a:rPr sz="788" b="1">
+              <a:rPr sz="735" b="1">
                 <a:solidFill>
                   <a:srgbClr val="FFFFFF"/>
                 </a:solidFill>
@@ -4166,23 +4166,23 @@
           <p:cNvPr id="53" name="">
             <a:extLst xmlns:a="http://schemas.openxmlformats.org/drawingml/2006/main">
               <a:ext uri="{FF2B5EF4-FFF2-40B4-BE49-F238E27FC236}">
-                <a16:creationId xmlns:a16="http://schemas.microsoft.com/office/drawing/2014/main" id="{A3EEAEFD-2C16-4A6B-9B67-F369A103D1E1}"/>
-              </a:ext>
-            </a:extLst>
-          </p:cNvPr>
-          <p:cNvSpPr>
-            <a:spLocks xmlns:a="http://schemas.openxmlformats.org/drawingml/2006/main" noGrp="1"/>
-          </p:cNvSpPr>
-          <p:nvPr/>
-        </p:nvSpPr>
-        <p:spPr>
-          <a:xfrm xmlns:a="http://schemas.openxmlformats.org/drawingml/2006/main">
-            <a:off x="5867400" y="1800225"/>
-            <a:ext cx="371475" cy="190500"/>
+                <a16:creationId xmlns:a16="http://schemas.microsoft.com/office/drawing/2014/main" id="{609451E3-EDD5-4C0D-A7F6-D0E5AAD49695}"/>
+              </a:ext>
+            </a:extLst>
+          </p:cNvPr>
+          <p:cNvSpPr>
+            <a:spLocks xmlns:a="http://schemas.openxmlformats.org/drawingml/2006/main" noGrp="1"/>
+          </p:cNvSpPr>
+          <p:nvPr/>
+        </p:nvSpPr>
+        <p:spPr>
+          <a:xfrm xmlns:a="http://schemas.openxmlformats.org/drawingml/2006/main">
+            <a:off x="5448300" y="1695450"/>
+            <a:ext cx="333375" cy="180975"/>
           </a:xfrm>
           <a:prstGeom xmlns:a="http://schemas.openxmlformats.org/drawingml/2006/main" prst="roundRect">
             <a:avLst>
-              <a:gd name="adj" fmla="val 40000"/>
+              <a:gd name="adj" fmla="val 42105"/>
             </a:avLst>
           </a:prstGeom>
           <a:solidFill xmlns:a="http://schemas.openxmlformats.org/drawingml/2006/main">
@@ -4196,12 +4196,12 @@
         </p:spPr>
         <p:txBody>
           <a:bodyPr xmlns:a="http://schemas.openxmlformats.org/drawingml/2006/main" anchor="ctr">
-            <a:normAutofit fontScale="45318"/>
-          </a:bodyPr>
-          <a:lstStyle xmlns:a="http://schemas.openxmlformats.org/drawingml/2006/main"/>
-          <a:p xmlns:a="http://schemas.openxmlformats.org/drawingml/2006/main">
-            <a:pPr>
-              <a:defRPr sz="788" b="1">
+            <a:normAutofit fontScale="40083"/>
+          </a:bodyPr>
+          <a:lstStyle xmlns:a="http://schemas.openxmlformats.org/drawingml/2006/main"/>
+          <a:p xmlns:a="http://schemas.openxmlformats.org/drawingml/2006/main">
+            <a:pPr>
+              <a:defRPr sz="735" b="1">
                 <a:solidFill>
                   <a:srgbClr val="FFFFFF"/>
                 </a:solidFill>
@@ -4211,7 +4211,7 @@
               </a:defRPr>
             </a:pPr>
             <a:r>
-              <a:rPr sz="788" b="1">
+              <a:rPr sz="735" b="1">
                 <a:solidFill>
                   <a:srgbClr val="FFFFFF"/>
                 </a:solidFill>
@@ -4229,23 +4229,23 @@
           <p:cNvPr id="54" name="">
             <a:extLst xmlns:a="http://schemas.openxmlformats.org/drawingml/2006/main">
               <a:ext uri="{FF2B5EF4-FFF2-40B4-BE49-F238E27FC236}">
-                <a16:creationId xmlns:a16="http://schemas.microsoft.com/office/drawing/2014/main" id="{8A4D8D52-62A2-4182-BB25-5F0076903E81}"/>
-              </a:ext>
-            </a:extLst>
-          </p:cNvPr>
-          <p:cNvSpPr>
-            <a:spLocks xmlns:a="http://schemas.openxmlformats.org/drawingml/2006/main" noGrp="1"/>
-          </p:cNvSpPr>
-          <p:nvPr/>
-        </p:nvSpPr>
-        <p:spPr>
-          <a:xfrm xmlns:a="http://schemas.openxmlformats.org/drawingml/2006/main">
-            <a:off x="4619625" y="2886075"/>
-            <a:ext cx="371475" cy="190500"/>
+                <a16:creationId xmlns:a16="http://schemas.microsoft.com/office/drawing/2014/main" id="{CBE42F5F-EC45-42CB-BFB8-A65531C2DB72}"/>
+              </a:ext>
+            </a:extLst>
+          </p:cNvPr>
+          <p:cNvSpPr>
+            <a:spLocks xmlns:a="http://schemas.openxmlformats.org/drawingml/2006/main" noGrp="1"/>
+          </p:cNvSpPr>
+          <p:nvPr/>
+        </p:nvSpPr>
+        <p:spPr>
+          <a:xfrm xmlns:a="http://schemas.openxmlformats.org/drawingml/2006/main">
+            <a:off x="4314825" y="2695575"/>
+            <a:ext cx="333375" cy="180975"/>
           </a:xfrm>
           <a:prstGeom xmlns:a="http://schemas.openxmlformats.org/drawingml/2006/main" prst="roundRect">
             <a:avLst>
-              <a:gd name="adj" fmla="val 40000"/>
+              <a:gd name="adj" fmla="val 42105"/>
             </a:avLst>
           </a:prstGeom>
           <a:solidFill xmlns:a="http://schemas.openxmlformats.org/drawingml/2006/main">
@@ -4259,12 +4259,12 @@
         </p:spPr>
         <p:txBody>
           <a:bodyPr xmlns:a="http://schemas.openxmlformats.org/drawingml/2006/main" anchor="ctr">
-            <a:normAutofit fontScale="45318"/>
-          </a:bodyPr>
-          <a:lstStyle xmlns:a="http://schemas.openxmlformats.org/drawingml/2006/main"/>
-          <a:p xmlns:a="http://schemas.openxmlformats.org/drawingml/2006/main">
-            <a:pPr>
-              <a:defRPr sz="788" b="1">
+            <a:normAutofit fontScale="40083"/>
+          </a:bodyPr>
+          <a:lstStyle xmlns:a="http://schemas.openxmlformats.org/drawingml/2006/main"/>
+          <a:p xmlns:a="http://schemas.openxmlformats.org/drawingml/2006/main">
+            <a:pPr>
+              <a:defRPr sz="735" b="1">
                 <a:solidFill>
                   <a:srgbClr val="FFFFFF"/>
                 </a:solidFill>
@@ -4274,7 +4274,7 @@
               </a:defRPr>
             </a:pPr>
             <a:r>
-              <a:rPr sz="788" b="1">
+              <a:rPr sz="735" b="1">
                 <a:solidFill>
                   <a:srgbClr val="FFFFFF"/>
                 </a:solidFill>
@@ -4292,23 +4292,23 @@
           <p:cNvPr id="55" name="">
             <a:extLst xmlns:a="http://schemas.openxmlformats.org/drawingml/2006/main">
               <a:ext uri="{FF2B5EF4-FFF2-40B4-BE49-F238E27FC236}">
-                <a16:creationId xmlns:a16="http://schemas.microsoft.com/office/drawing/2014/main" id="{F52D9A31-89D5-41F2-A557-AB004DDA0CDE}"/>
-              </a:ext>
-            </a:extLst>
-          </p:cNvPr>
-          <p:cNvSpPr>
-            <a:spLocks xmlns:a="http://schemas.openxmlformats.org/drawingml/2006/main" noGrp="1"/>
-          </p:cNvSpPr>
-          <p:nvPr/>
-        </p:nvSpPr>
-        <p:spPr>
-          <a:xfrm xmlns:a="http://schemas.openxmlformats.org/drawingml/2006/main">
-            <a:off x="5010150" y="2886075"/>
-            <a:ext cx="371475" cy="190500"/>
+                <a16:creationId xmlns:a16="http://schemas.microsoft.com/office/drawing/2014/main" id="{268B3E93-86EC-476E-B503-1AA48F1E3CA1}"/>
+              </a:ext>
+            </a:extLst>
+          </p:cNvPr>
+          <p:cNvSpPr>
+            <a:spLocks xmlns:a="http://schemas.openxmlformats.org/drawingml/2006/main" noGrp="1"/>
+          </p:cNvSpPr>
+          <p:nvPr/>
+        </p:nvSpPr>
+        <p:spPr>
+          <a:xfrm xmlns:a="http://schemas.openxmlformats.org/drawingml/2006/main">
+            <a:off x="4667250" y="2695575"/>
+            <a:ext cx="333375" cy="180975"/>
           </a:xfrm>
           <a:prstGeom xmlns:a="http://schemas.openxmlformats.org/drawingml/2006/main" prst="roundRect">
             <a:avLst>
-              <a:gd name="adj" fmla="val 40000"/>
+              <a:gd name="adj" fmla="val 42105"/>
             </a:avLst>
           </a:prstGeom>
           <a:solidFill xmlns:a="http://schemas.openxmlformats.org/drawingml/2006/main">
@@ -4322,12 +4322,12 @@
         </p:spPr>
         <p:txBody>
           <a:bodyPr xmlns:a="http://schemas.openxmlformats.org/drawingml/2006/main" anchor="ctr">
-            <a:normAutofit fontScale="45318"/>
-          </a:bodyPr>
-          <a:lstStyle xmlns:a="http://schemas.openxmlformats.org/drawingml/2006/main"/>
-          <a:p xmlns:a="http://schemas.openxmlformats.org/drawingml/2006/main">
-            <a:pPr>
-              <a:defRPr sz="788" b="1">
+            <a:normAutofit fontScale="40083"/>
+          </a:bodyPr>
+          <a:lstStyle xmlns:a="http://schemas.openxmlformats.org/drawingml/2006/main"/>
+          <a:p xmlns:a="http://schemas.openxmlformats.org/drawingml/2006/main">
+            <a:pPr>
+              <a:defRPr sz="735" b="1">
                 <a:solidFill>
                   <a:srgbClr val="FFFFFF"/>
                 </a:solidFill>
@@ -4337,7 +4337,7 @@
               </a:defRPr>
             </a:pPr>
             <a:r>
-              <a:rPr sz="788" b="1">
+              <a:rPr sz="735" b="1">
                 <a:solidFill>
                   <a:srgbClr val="FFFFFF"/>
                 </a:solidFill>
@@ -4355,23 +4355,23 @@
           <p:cNvPr id="56" name="">
             <a:extLst xmlns:a="http://schemas.openxmlformats.org/drawingml/2006/main">
               <a:ext uri="{FF2B5EF4-FFF2-40B4-BE49-F238E27FC236}">
-                <a16:creationId xmlns:a16="http://schemas.microsoft.com/office/drawing/2014/main" id="{E97F8E95-8AAE-41B8-ADF4-F02C4FFA9E43}"/>
-              </a:ext>
-            </a:extLst>
-          </p:cNvPr>
-          <p:cNvSpPr>
-            <a:spLocks xmlns:a="http://schemas.openxmlformats.org/drawingml/2006/main" noGrp="1"/>
-          </p:cNvSpPr>
-          <p:nvPr/>
-        </p:nvSpPr>
-        <p:spPr>
-          <a:xfrm xmlns:a="http://schemas.openxmlformats.org/drawingml/2006/main">
-            <a:off x="5010150" y="1800225"/>
-            <a:ext cx="371475" cy="190500"/>
+                <a16:creationId xmlns:a16="http://schemas.microsoft.com/office/drawing/2014/main" id="{30D279CE-FE95-44F4-9EDE-231080B48A1E}"/>
+              </a:ext>
+            </a:extLst>
+          </p:cNvPr>
+          <p:cNvSpPr>
+            <a:spLocks xmlns:a="http://schemas.openxmlformats.org/drawingml/2006/main" noGrp="1"/>
+          </p:cNvSpPr>
+          <p:nvPr/>
+        </p:nvSpPr>
+        <p:spPr>
+          <a:xfrm xmlns:a="http://schemas.openxmlformats.org/drawingml/2006/main">
+            <a:off x="4667250" y="1695450"/>
+            <a:ext cx="333375" cy="180975"/>
           </a:xfrm>
           <a:prstGeom xmlns:a="http://schemas.openxmlformats.org/drawingml/2006/main" prst="roundRect">
             <a:avLst>
-              <a:gd name="adj" fmla="val 40000"/>
+              <a:gd name="adj" fmla="val 42105"/>
             </a:avLst>
           </a:prstGeom>
           <a:solidFill xmlns:a="http://schemas.openxmlformats.org/drawingml/2006/main">
@@ -4385,12 +4385,12 @@
         </p:spPr>
         <p:txBody>
           <a:bodyPr xmlns:a="http://schemas.openxmlformats.org/drawingml/2006/main" anchor="ctr">
-            <a:normAutofit fontScale="45318"/>
-          </a:bodyPr>
-          <a:lstStyle xmlns:a="http://schemas.openxmlformats.org/drawingml/2006/main"/>
-          <a:p xmlns:a="http://schemas.openxmlformats.org/drawingml/2006/main">
-            <a:pPr>
-              <a:defRPr sz="788" b="1">
+            <a:normAutofit fontScale="40083"/>
+          </a:bodyPr>
+          <a:lstStyle xmlns:a="http://schemas.openxmlformats.org/drawingml/2006/main"/>
+          <a:p xmlns:a="http://schemas.openxmlformats.org/drawingml/2006/main">
+            <a:pPr>
+              <a:defRPr sz="735" b="1">
                 <a:solidFill>
                   <a:srgbClr val="FFFFFF"/>
                 </a:solidFill>
@@ -4400,7 +4400,7 @@
               </a:defRPr>
             </a:pPr>
             <a:r>
-              <a:rPr sz="788" b="1">
+              <a:rPr sz="735" b="1">
                 <a:solidFill>
                   <a:srgbClr val="FFFFFF"/>
                 </a:solidFill>
@@ -4418,19 +4418,19 @@
           <p:cNvPr id="57" name="">
             <a:extLst xmlns:a="http://schemas.openxmlformats.org/drawingml/2006/main">
               <a:ext uri="{FF2B5EF4-FFF2-40B4-BE49-F238E27FC236}">
-                <a16:creationId xmlns:a16="http://schemas.microsoft.com/office/drawing/2014/main" id="{6D7096C6-04A9-4D86-B8E2-3DCDCF3520F9}"/>
-              </a:ext>
-            </a:extLst>
-          </p:cNvPr>
-          <p:cNvSpPr>
-            <a:spLocks xmlns:a="http://schemas.openxmlformats.org/drawingml/2006/main" noGrp="1"/>
-          </p:cNvSpPr>
-          <p:nvPr/>
-        </p:nvSpPr>
-        <p:spPr>
-          <a:xfrm xmlns:a="http://schemas.openxmlformats.org/drawingml/2006/main">
-            <a:off x="514350" y="5981700"/>
-            <a:ext cx="10382250" cy="247650"/>
+                <a16:creationId xmlns:a16="http://schemas.microsoft.com/office/drawing/2014/main" id="{3497CFE2-E870-4F67-8FDF-729EE75188EA}"/>
+              </a:ext>
+            </a:extLst>
+          </p:cNvPr>
+          <p:cNvSpPr>
+            <a:spLocks xmlns:a="http://schemas.openxmlformats.org/drawingml/2006/main" noGrp="1"/>
+          </p:cNvSpPr>
+          <p:nvPr/>
+        </p:nvSpPr>
+        <p:spPr>
+          <a:xfrm xmlns:a="http://schemas.openxmlformats.org/drawingml/2006/main">
+            <a:off x="476250" y="5581650"/>
+            <a:ext cx="8191500" cy="228600"/>
           </a:xfrm>
           <a:prstGeom xmlns:a="http://schemas.openxmlformats.org/drawingml/2006/main" prst="rect">
             <a:avLst/>
@@ -4442,12 +4442,12 @@
         </p:spPr>
         <p:txBody>
           <a:bodyPr xmlns:a="http://schemas.openxmlformats.org/drawingml/2006/main" anchor="ctr">
-            <a:normAutofit fontScale="91111"/>
-          </a:bodyPr>
-          <a:lstStyle xmlns:a="http://schemas.openxmlformats.org/drawingml/2006/main"/>
-          <a:p xmlns:a="http://schemas.openxmlformats.org/drawingml/2006/main">
-            <a:pPr>
-              <a:defRPr sz="1125" b="1">
+            <a:normAutofit fontScale="85714"/>
+          </a:bodyPr>
+          <a:lstStyle xmlns:a="http://schemas.openxmlformats.org/drawingml/2006/main"/>
+          <a:p xmlns:a="http://schemas.openxmlformats.org/drawingml/2006/main">
+            <a:pPr>
+              <a:defRPr sz="1050" b="1">
                 <a:solidFill>
                   <a:srgbClr val="172B3A"/>
                 </a:solidFill>
@@ -4457,7 +4457,7 @@
               </a:defRPr>
             </a:pPr>
             <a:r>
-              <a:rPr sz="1125" b="1">
+              <a:rPr sz="1050" b="1">
                 <a:solidFill>
                   <a:srgbClr val="172B3A"/>
                 </a:solidFill>
@@ -4475,19 +4475,19 @@
           <p:cNvPr id="58" name="">
             <a:extLst xmlns:a="http://schemas.openxmlformats.org/drawingml/2006/main">
               <a:ext uri="{FF2B5EF4-FFF2-40B4-BE49-F238E27FC236}">
-                <a16:creationId xmlns:a16="http://schemas.microsoft.com/office/drawing/2014/main" id="{AD0619B9-A23E-4B4D-852B-3D5CB6A5CB7E}"/>
-              </a:ext>
-            </a:extLst>
-          </p:cNvPr>
-          <p:cNvSpPr>
-            <a:spLocks xmlns:a="http://schemas.openxmlformats.org/drawingml/2006/main" noGrp="1"/>
-          </p:cNvSpPr>
-          <p:nvPr/>
-        </p:nvSpPr>
-        <p:spPr>
-          <a:xfrm xmlns:a="http://schemas.openxmlformats.org/drawingml/2006/main">
-            <a:off x="514350" y="6286500"/>
-            <a:ext cx="10382250" cy="209550"/>
+                <a16:creationId xmlns:a16="http://schemas.microsoft.com/office/drawing/2014/main" id="{4C2B2AC0-FC95-4941-A3F3-D4EB1741AD31}"/>
+              </a:ext>
+            </a:extLst>
+          </p:cNvPr>
+          <p:cNvSpPr>
+            <a:spLocks xmlns:a="http://schemas.openxmlformats.org/drawingml/2006/main" noGrp="1"/>
+          </p:cNvSpPr>
+          <p:nvPr/>
+        </p:nvSpPr>
+        <p:spPr>
+          <a:xfrm xmlns:a="http://schemas.openxmlformats.org/drawingml/2006/main">
+            <a:off x="476250" y="5905500"/>
+            <a:ext cx="8191500" cy="361950"/>
           </a:xfrm>
           <a:prstGeom xmlns:a="http://schemas.openxmlformats.org/drawingml/2006/main" prst="rect">
             <a:avLst/>
@@ -4499,12 +4499,12 @@
         </p:spPr>
         <p:txBody>
           <a:bodyPr xmlns:a="http://schemas.openxmlformats.org/drawingml/2006/main" anchor="ctr">
-            <a:normAutofit fontScale="79487"/>
-          </a:bodyPr>
-          <a:lstStyle xmlns:a="http://schemas.openxmlformats.org/drawingml/2006/main"/>
-          <a:p xmlns:a="http://schemas.openxmlformats.org/drawingml/2006/main">
-            <a:pPr>
-              <a:defRPr sz="975" b="0">
+            <a:normAutofit fontScale="100000"/>
+          </a:bodyPr>
+          <a:lstStyle xmlns:a="http://schemas.openxmlformats.org/drawingml/2006/main"/>
+          <a:p xmlns:a="http://schemas.openxmlformats.org/drawingml/2006/main">
+            <a:pPr>
+              <a:defRPr sz="938" b="0">
                 <a:solidFill>
                   <a:srgbClr val="1C2C3A"/>
                 </a:solidFill>
@@ -4514,7 +4514,7 @@
               </a:defRPr>
             </a:pPr>
             <a:r>
-              <a:rPr sz="975" b="0">
+              <a:rPr sz="938" b="0">
                 <a:solidFill>
                   <a:srgbClr val="1C2C3A"/>
                 </a:solidFill>
@@ -4522,7 +4522,7 @@
                 <a:ea typeface="Microsoft YaHei"/>
                 <a:cs typeface="Microsoft YaHei"/>
               </a:rPr>
-              <a:t>极高风险 R01、R08、R10、R13 进入每周专项跟踪；触发后按风险登记册启动措施并评估正式里程碑影响。</a:t>
+              <a:t>极高风险 R01、R08、R10、R13 进入每周专项跟踪；触发后启动措施并评估正式里程碑影响。</a:t>
             </a:r>
           </a:p>
         </p:txBody>
@@ -4532,19 +4532,19 @@
           <p:cNvPr id="59" name="">
             <a:extLst xmlns:a="http://schemas.openxmlformats.org/drawingml/2006/main">
               <a:ext uri="{FF2B5EF4-FFF2-40B4-BE49-F238E27FC236}">
-                <a16:creationId xmlns:a16="http://schemas.microsoft.com/office/drawing/2014/main" id="{F04A3B5C-368B-4194-A8FF-F7D72DD3E687}"/>
-              </a:ext>
-            </a:extLst>
-          </p:cNvPr>
-          <p:cNvSpPr>
-            <a:spLocks xmlns:a="http://schemas.openxmlformats.org/drawingml/2006/main" noGrp="1"/>
-          </p:cNvSpPr>
-          <p:nvPr/>
-        </p:nvSpPr>
-        <p:spPr>
-          <a:xfrm xmlns:a="http://schemas.openxmlformats.org/drawingml/2006/main">
-            <a:off x="10382250" y="6572250"/>
-            <a:ext cx="1238250" cy="171450"/>
+                <a16:creationId xmlns:a16="http://schemas.microsoft.com/office/drawing/2014/main" id="{5821E9EC-D7E6-4A0A-9448-2E31FCA32C28}"/>
+              </a:ext>
+            </a:extLst>
+          </p:cNvPr>
+          <p:cNvSpPr>
+            <a:spLocks xmlns:a="http://schemas.openxmlformats.org/drawingml/2006/main" noGrp="1"/>
+          </p:cNvSpPr>
+          <p:nvPr/>
+        </p:nvSpPr>
+        <p:spPr>
+          <a:xfrm xmlns:a="http://schemas.openxmlformats.org/drawingml/2006/main">
+            <a:off x="7524750" y="6477000"/>
+            <a:ext cx="1143000" cy="171450"/>
           </a:xfrm>
           <a:prstGeom xmlns:a="http://schemas.openxmlformats.org/drawingml/2006/main" prst="rect">
             <a:avLst/>
@@ -4587,7 +4587,7 @@
     </p:spTree>
     <p:extLst>
       <p:ext uri="{BB962C8B-B14F-4D97-AF65-F5344CB8AC3E}">
-        <p14:creationId xmlns:p14="http://schemas.microsoft.com/office/powerpoint/2010/main" val="1719298444"/>
+        <p14:creationId xmlns:p14="http://schemas.microsoft.com/office/powerpoint/2010/main" val="1897215387"/>
       </p:ext>
     </p:extLst>
   </p:cSld>

</xml_diff>